<commit_message>
docs: update Technical_Report.pdf and presentation slides
</commit_message>
<xml_diff>
--- a/docs/InsightAgent_presentation.pptx
+++ b/docs/InsightAgent_presentation.pptx
@@ -18,6 +18,8 @@
     <p:sldId id="263" r:id="rId11"/>
     <p:sldId id="264" r:id="rId12"/>
     <p:sldId id="265" r:id="rId13"/>
+    <p:sldId id="268" r:id="rId14"/>
+    <p:sldId id="269" r:id="rId15"/>
   </p:sldIdLst>
   <p:sldSz cx="12192000" cy="6858000"/>
   <p:notesSz cx="6858000" cy="12192000"/>
@@ -548,6 +550,174 @@
 </file>
 
 <file path=ppt/notesSlides/notesSlide10.xml><?xml version="1.0" encoding="utf-8"?>
+<p:notes xmlns:a="http://schemas.openxmlformats.org/drawingml/2006/main" xmlns:r="http://schemas.openxmlformats.org/officeDocument/2006/relationships" xmlns:p="http://schemas.openxmlformats.org/presentationml/2006/main">
+  <p:cSld>
+    <p:spTree>
+      <p:nvGrpSpPr>
+        <p:cNvPr id="1" name=""/>
+        <p:cNvGrpSpPr/>
+        <p:nvPr/>
+      </p:nvGrpSpPr>
+      <p:grpSpPr>
+        <a:xfrm>
+          <a:off x="0" y="0"/>
+          <a:ext cx="0" cy="0"/>
+          <a:chOff x="0" y="0"/>
+          <a:chExt cx="0" cy="0"/>
+        </a:xfrm>
+      </p:grpSpPr>
+      <p:sp>
+        <p:nvSpPr>
+          <p:cNvPr id="2" name="Slide Image Placeholder 1"/>
+          <p:cNvSpPr>
+            <a:spLocks noGrp="1" noRot="1" noChangeAspect="1"/>
+          </p:cNvSpPr>
+          <p:nvPr>
+            <p:ph type="sldImg"/>
+          </p:nvPr>
+        </p:nvSpPr>
+        <p:spPr/>
+      </p:sp>
+      <p:sp>
+        <p:nvSpPr>
+          <p:cNvPr id="3" name="Notes Placeholder 2"/>
+          <p:cNvSpPr>
+            <a:spLocks noGrp="1"/>
+          </p:cNvSpPr>
+          <p:nvPr>
+            <p:ph type="body" idx="1"/>
+          </p:nvPr>
+        </p:nvSpPr>
+        <p:spPr/>
+        <p:txBody>
+          <a:bodyPr/>
+          <a:lstStyle/>
+          <a:p>
+            <a:r>
+              <a:rPr lang="en-US" dirty="0"/>
+              <a:t>[Sources]
+- User-provided technical report PDF, p.3 Figure 2 and Section 5.2.
+- User-provided API documentation PDF, p.6 (skill-specific error statuses).</a:t>
+            </a:r>
+            <a:endParaRPr lang="en-US" dirty="0"/>
+          </a:p>
+        </p:txBody>
+      </p:sp>
+      <p:sp>
+        <p:nvSpPr>
+          <p:cNvPr id="4" name="Slide Number Placeholder 3"/>
+          <p:cNvSpPr>
+            <a:spLocks noGrp="1"/>
+          </p:cNvSpPr>
+          <p:nvPr>
+            <p:ph type="sldNum" sz="quarter" idx="10"/>
+          </p:nvPr>
+        </p:nvSpPr>
+        <p:spPr/>
+        <p:txBody>
+          <a:bodyPr/>
+          <a:lstStyle/>
+          <a:p>
+            <a:fld id="{F7021451-1387-4CA6-816F-3879F97B5CBC}" type="slidenum">
+              <a:rPr lang="en-US"/>
+            </a:fld>
+            <a:endParaRPr lang="en-US"/>
+          </a:p>
+        </p:txBody>
+      </p:sp>
+    </p:spTree>
+  </p:cSld>
+  <p:clrMapOvr>
+    <a:masterClrMapping/>
+  </p:clrMapOvr>
+</p:notes>
+</file>
+
+<file path=ppt/notesSlides/notesSlide11.xml><?xml version="1.0" encoding="utf-8"?>
+<p:notes xmlns:a="http://schemas.openxmlformats.org/drawingml/2006/main" xmlns:r="http://schemas.openxmlformats.org/officeDocument/2006/relationships" xmlns:p="http://schemas.openxmlformats.org/presentationml/2006/main">
+  <p:cSld>
+    <p:spTree>
+      <p:nvGrpSpPr>
+        <p:cNvPr id="1" name=""/>
+        <p:cNvGrpSpPr/>
+        <p:nvPr/>
+      </p:nvGrpSpPr>
+      <p:grpSpPr>
+        <a:xfrm>
+          <a:off x="0" y="0"/>
+          <a:ext cx="0" cy="0"/>
+          <a:chOff x="0" y="0"/>
+          <a:chExt cx="0" cy="0"/>
+        </a:xfrm>
+      </p:grpSpPr>
+      <p:sp>
+        <p:nvSpPr>
+          <p:cNvPr id="2" name="Slide Image Placeholder 1"/>
+          <p:cNvSpPr>
+            <a:spLocks noGrp="1" noRot="1" noChangeAspect="1"/>
+          </p:cNvSpPr>
+          <p:nvPr>
+            <p:ph type="sldImg"/>
+          </p:nvPr>
+        </p:nvSpPr>
+        <p:spPr/>
+      </p:sp>
+      <p:sp>
+        <p:nvSpPr>
+          <p:cNvPr id="3" name="Notes Placeholder 2"/>
+          <p:cNvSpPr>
+            <a:spLocks noGrp="1"/>
+          </p:cNvSpPr>
+          <p:nvPr>
+            <p:ph type="body" idx="1"/>
+          </p:nvPr>
+        </p:nvSpPr>
+        <p:spPr/>
+        <p:txBody>
+          <a:bodyPr/>
+          <a:lstStyle/>
+          <a:p>
+            <a:r>
+              <a:rPr lang="en-US" dirty="0"/>
+              <a:t>[Sources]
+- User-provided technical report PDF, p.3 Figure 2 and Section 5.2.
+- User-provided API documentation PDF, p.6 (skill-specific error statuses).</a:t>
+            </a:r>
+            <a:endParaRPr lang="en-US" dirty="0"/>
+          </a:p>
+        </p:txBody>
+      </p:sp>
+      <p:sp>
+        <p:nvSpPr>
+          <p:cNvPr id="4" name="Slide Number Placeholder 3"/>
+          <p:cNvSpPr>
+            <a:spLocks noGrp="1"/>
+          </p:cNvSpPr>
+          <p:nvPr>
+            <p:ph type="sldNum" sz="quarter" idx="10"/>
+          </p:nvPr>
+        </p:nvSpPr>
+        <p:spPr/>
+        <p:txBody>
+          <a:bodyPr/>
+          <a:lstStyle/>
+          <a:p>
+            <a:fld id="{F7021451-1387-4CA6-816F-3879F97B5CBC}" type="slidenum">
+              <a:rPr lang="en-US"/>
+            </a:fld>
+            <a:endParaRPr lang="en-US"/>
+          </a:p>
+        </p:txBody>
+      </p:sp>
+    </p:spTree>
+  </p:cSld>
+  <p:clrMapOvr>
+    <a:masterClrMapping/>
+  </p:clrMapOvr>
+</p:notes>
+</file>
+
+<file path=ppt/notesSlides/notesSlide12.xml><?xml version="1.0" encoding="utf-8"?>
 <p:notes xmlns:a="http://schemas.openxmlformats.org/drawingml/2006/main" xmlns:r="http://schemas.openxmlformats.org/officeDocument/2006/relationships" xmlns:p="http://schemas.openxmlformats.org/presentationml/2006/main">
   <p:cSld>
     <p:spTree>
@@ -2541,8 +2711,8 @@
         </p:nvSpPr>
         <p:spPr>
           <a:xfrm>
-            <a:off x="530225" y="1305687"/>
-            <a:ext cx="3657600" cy="201168"/>
+            <a:off x="530225" y="1305560"/>
+            <a:ext cx="6099175" cy="182880"/>
           </a:xfrm>
           <a:prstGeom prst="rect">
             <a:avLst/>
@@ -2557,14 +2727,18 @@
               <a:buNone/>
             </a:pPr>
             <a:r>
-              <a:rPr lang="en-US" sz="1600" b="1" dirty="0">
+              <a:rPr lang="en-US" sz="2400" b="1" dirty="0">
                 <a:solidFill>
                   <a:srgbClr val="0F172A"/>
                 </a:solidFill>
               </a:rPr>
               <a:t>Three-phase policy orchestration</a:t>
             </a:r>
-            <a:endParaRPr lang="en-US" sz="1300" dirty="0"/>
+            <a:endParaRPr lang="en-US" sz="2400" b="1" dirty="0">
+              <a:solidFill>
+                <a:srgbClr val="0F172A"/>
+              </a:solidFill>
+            </a:endParaRPr>
           </a:p>
         </p:txBody>
       </p:sp>
@@ -2576,8 +2750,8 @@
         </p:nvSpPr>
         <p:spPr>
           <a:xfrm>
-            <a:off x="514350" y="1565656"/>
-            <a:ext cx="4937760" cy="182880"/>
+            <a:off x="514350" y="2035175"/>
+            <a:ext cx="5759450" cy="685800"/>
           </a:xfrm>
           <a:prstGeom prst="rect">
             <a:avLst/>
@@ -2592,14 +2766,54 @@
               <a:buNone/>
             </a:pPr>
             <a:r>
-              <a:rPr lang="en-US" sz="1250" dirty="0">
+              <a:rPr lang="en-US" dirty="0">
                 <a:solidFill>
                   <a:srgbClr val="334155"/>
                 </a:solidFill>
               </a:rPr>
-              <a:t>AST validation → SQL filtering → isolated subprocess</a:t>
-            </a:r>
-            <a:endParaRPr lang="en-US" sz="1250" dirty="0"/>
+              <a:t>AST validation → </a:t>
+            </a:r>
+            <a:endParaRPr lang="en-US" dirty="0">
+              <a:solidFill>
+                <a:srgbClr val="334155"/>
+              </a:solidFill>
+            </a:endParaRPr>
+          </a:p>
+          <a:p>
+            <a:pPr marL="0" indent="0">
+              <a:buNone/>
+            </a:pPr>
+            <a:r>
+              <a:rPr lang="en-US" dirty="0">
+                <a:solidFill>
+                  <a:srgbClr val="334155"/>
+                </a:solidFill>
+              </a:rPr>
+              <a:t>SQL filtering → </a:t>
+            </a:r>
+            <a:endParaRPr lang="en-US" dirty="0">
+              <a:solidFill>
+                <a:srgbClr val="334155"/>
+              </a:solidFill>
+            </a:endParaRPr>
+          </a:p>
+          <a:p>
+            <a:pPr marL="0" indent="0">
+              <a:buNone/>
+            </a:pPr>
+            <a:r>
+              <a:rPr lang="en-US" dirty="0">
+                <a:solidFill>
+                  <a:srgbClr val="334155"/>
+                </a:solidFill>
+              </a:rPr>
+              <a:t>isolated subprocess</a:t>
+            </a:r>
+            <a:endParaRPr lang="en-US" dirty="0">
+              <a:solidFill>
+                <a:srgbClr val="334155"/>
+              </a:solidFill>
+            </a:endParaRPr>
           </a:p>
         </p:txBody>
       </p:sp>
@@ -2627,14 +2841,18 @@
               <a:buNone/>
             </a:pPr>
             <a:r>
-              <a:rPr lang="en-US" sz="1600" b="1" dirty="0">
+              <a:rPr lang="en-US" sz="2000" b="1" dirty="0">
                 <a:solidFill>
                   <a:srgbClr val="0F172A"/>
                 </a:solidFill>
               </a:rPr>
               <a:t>Main protections</a:t>
             </a:r>
-            <a:endParaRPr lang="en-US" sz="1600" dirty="0"/>
+            <a:endParaRPr lang="en-US" sz="2000" b="1" dirty="0">
+              <a:solidFill>
+                <a:srgbClr val="0F172A"/>
+              </a:solidFill>
+            </a:endParaRPr>
           </a:p>
         </p:txBody>
       </p:sp>
@@ -2662,70 +2880,74 @@
               <a:buNone/>
             </a:pPr>
             <a:r>
-              <a:rPr lang="en-US" sz="1150" dirty="0">
+              <a:rPr lang="en-US" sz="1400" dirty="0">
                 <a:solidFill>
                   <a:srgbClr val="334155"/>
                 </a:solidFill>
               </a:rPr>
               <a:t>• app_ro database account is SELECT-only</a:t>
             </a:r>
-            <a:endParaRPr lang="en-US" sz="1150" dirty="0"/>
+            <a:endParaRPr lang="en-US" sz="1400" dirty="0"/>
           </a:p>
           <a:p>
             <a:pPr marL="0" indent="0">
               <a:buNone/>
             </a:pPr>
             <a:r>
-              <a:rPr lang="en-US" sz="1150" dirty="0">
+              <a:rPr lang="en-US" sz="1400" dirty="0">
                 <a:solidFill>
                   <a:srgbClr val="334155"/>
                 </a:solidFill>
               </a:rPr>
               <a:t>• AST blocks dangerous imports and calls</a:t>
             </a:r>
-            <a:endParaRPr lang="en-US" sz="1150" dirty="0"/>
+            <a:endParaRPr lang="en-US" sz="1400" dirty="0"/>
           </a:p>
           <a:p>
             <a:pPr marL="0" indent="0">
               <a:buNone/>
             </a:pPr>
             <a:r>
-              <a:rPr lang="en-US" sz="1150" dirty="0">
+              <a:rPr lang="en-US" sz="1400" dirty="0">
                 <a:solidFill>
                   <a:srgbClr val="334155"/>
                 </a:solidFill>
               </a:rPr>
               <a:t>• read_sql() blocks non-SELECT statements</a:t>
             </a:r>
-            <a:endParaRPr lang="en-US" sz="1150" dirty="0"/>
+            <a:endParaRPr lang="en-US" sz="1400" dirty="0"/>
           </a:p>
           <a:p>
             <a:pPr marL="0" indent="0">
               <a:buNone/>
             </a:pPr>
             <a:r>
-              <a:rPr lang="en-US" sz="1150" dirty="0">
+              <a:rPr lang="en-US" sz="1400" dirty="0">
                 <a:solidFill>
                   <a:srgbClr val="334155"/>
                 </a:solidFill>
               </a:rPr>
               <a:t>• worker process enforces timeout and failure containment</a:t>
             </a:r>
-            <a:endParaRPr lang="en-US" sz="1150" dirty="0"/>
+            <a:endParaRPr lang="en-US" sz="1400" dirty="0"/>
           </a:p>
           <a:p>
             <a:pPr marL="0" indent="0">
               <a:buNone/>
             </a:pPr>
             <a:r>
-              <a:rPr lang="en-US" sz="1150" dirty="0">
+              <a:rPr lang="en-US" sz="1400" dirty="0">
                 <a:solidFill>
                   <a:srgbClr val="334155"/>
                 </a:solidFill>
               </a:rPr>
               <a:t>• the API returns structured error types instead of raw crashes</a:t>
             </a:r>
-            <a:endParaRPr lang="en-US" sz="1150" dirty="0"/>
+            <a:endParaRPr lang="en-US" sz="1400" dirty="0">
+              <a:solidFill>
+                <a:srgbClr val="334155"/>
+              </a:solidFill>
+            </a:endParaRPr>
           </a:p>
         </p:txBody>
       </p:sp>
@@ -2741,8 +2963,8 @@
         </p:nvSpPr>
         <p:spPr>
           <a:xfrm>
-            <a:off x="11567160" y="6473952"/>
-            <a:ext cx="274320" cy="182880"/>
+            <a:off x="11567160" y="6473825"/>
+            <a:ext cx="347345" cy="182880"/>
           </a:xfrm>
           <a:prstGeom prst="rect">
             <a:avLst/>
@@ -2795,6 +3017,2235 @@
           </a:prstGeom>
         </p:spPr>
       </p:pic>
+    </p:spTree>
+  </p:cSld>
+  <p:clrMapOvr>
+    <a:masterClrMapping/>
+  </p:clrMapOvr>
+</p:sld>
+</file>
+
+<file path=ppt/slides/slide11.xml><?xml version="1.0" encoding="utf-8"?>
+<p:sld xmlns:a="http://schemas.openxmlformats.org/drawingml/2006/main" xmlns:r="http://schemas.openxmlformats.org/officeDocument/2006/relationships" xmlns:p="http://schemas.openxmlformats.org/presentationml/2006/main">
+  <p:cSld>
+    <p:spTree>
+      <p:nvGrpSpPr>
+        <p:cNvPr id="1" name=""/>
+        <p:cNvGrpSpPr/>
+        <p:nvPr/>
+      </p:nvGrpSpPr>
+      <p:grpSpPr>
+        <a:xfrm>
+          <a:off x="0" y="0"/>
+          <a:ext cx="0" cy="0"/>
+          <a:chOff x="0" y="0"/>
+          <a:chExt cx="0" cy="0"/>
+        </a:xfrm>
+      </p:grpSpPr>
+      <p:sp>
+        <p:nvSpPr>
+          <p:cNvPr id="2" name="Text 0"/>
+          <p:cNvSpPr/>
+          <p:nvPr/>
+        </p:nvSpPr>
+        <p:spPr>
+          <a:xfrm>
+            <a:off x="502920" y="347472"/>
+            <a:ext cx="7863840" cy="411480"/>
+          </a:xfrm>
+          <a:prstGeom prst="rect">
+            <a:avLst/>
+          </a:prstGeom>
+          <a:noFill/>
+        </p:spPr>
+        <p:txBody>
+          <a:bodyPr wrap="square" lIns="0" tIns="0" rIns="0" bIns="0" rtlCol="0" anchor="ctr"/>
+          <a:lstStyle/>
+          <a:p>
+            <a:pPr marL="0" indent="0">
+              <a:buNone/>
+            </a:pPr>
+            <a:r>
+              <a:rPr sz="2400" b="1">
+                <a:solidFill>
+                  <a:srgbClr val="282828"/>
+                </a:solidFill>
+                <a:latin typeface="Aptos"/>
+                <a:sym typeface="+mn-ea"/>
+              </a:rPr>
+              <a:t>Testing Summary</a:t>
+            </a:r>
+            <a:endParaRPr lang="en-US" sz="2400" dirty="0"/>
+          </a:p>
+        </p:txBody>
+      </p:sp>
+      <p:sp>
+        <p:nvSpPr>
+          <p:cNvPr id="3" name="Text 1"/>
+          <p:cNvSpPr/>
+          <p:nvPr/>
+        </p:nvSpPr>
+        <p:spPr>
+          <a:xfrm>
+            <a:off x="530352" y="804672"/>
+            <a:ext cx="10789920" cy="274320"/>
+          </a:xfrm>
+          <a:prstGeom prst="rect">
+            <a:avLst/>
+          </a:prstGeom>
+          <a:noFill/>
+        </p:spPr>
+        <p:txBody>
+          <a:bodyPr wrap="square" lIns="0" tIns="0" rIns="0" bIns="0" rtlCol="0" anchor="ctr"/>
+          <a:lstStyle/>
+          <a:p>
+            <a:pPr marL="0" indent="0">
+              <a:buNone/>
+            </a:pPr>
+            <a:r>
+              <a:rPr sz="1100">
+                <a:solidFill>
+                  <a:srgbClr val="5F5F5F"/>
+                </a:solidFill>
+                <a:latin typeface="Aptos"/>
+                <a:sym typeface="+mn-ea"/>
+              </a:rPr>
+              <a:t>93/93 tests passed in 5m 04s, covering security checks, CRUD, negative API cases, multistep agent reasoning, and anomaly detection.</a:t>
+            </a:r>
+            <a:endParaRPr lang="en-US" sz="1100" dirty="0"/>
+          </a:p>
+        </p:txBody>
+      </p:sp>
+      <p:sp>
+        <p:nvSpPr>
+          <p:cNvPr id="25" name="Slide Number Placeholder 0"/>
+          <p:cNvSpPr>
+            <a:spLocks noGrp="1"/>
+          </p:cNvSpPr>
+          <p:nvPr>
+            <p:ph type="sldNum" sz="quarter" idx="4294967295"/>
+          </p:nvPr>
+        </p:nvSpPr>
+        <p:spPr>
+          <a:xfrm>
+            <a:off x="11567160" y="6473825"/>
+            <a:ext cx="407035" cy="182880"/>
+          </a:xfrm>
+          <a:prstGeom prst="rect">
+            <a:avLst/>
+          </a:prstGeom>
+        </p:spPr>
+        <p:txBody>
+          <a:bodyPr/>
+          <a:lstStyle>
+            <a:lvl1pPr>
+              <a:defRPr sz="1000">
+                <a:solidFill>
+                  <a:srgbClr val="64748B"/>
+                </a:solidFill>
+                <a:latin typeface="Aptos"/>
+                <a:ea typeface="Aptos"/>
+                <a:cs typeface="Aptos"/>
+              </a:defRPr>
+            </a:lvl1pPr>
+          </a:lstStyle>
+          <a:p>
+            <a:pPr algn="ctr"/>
+            <a:fld id="{F7021451-1387-4CA6-816F-3879F97B5CBC}" type="slidenum">
+              <a:rPr lang="en-US" b="0"/>
+            </a:fld>
+            <a:endParaRPr lang="en-US"/>
+          </a:p>
+        </p:txBody>
+      </p:sp>
+      <p:sp>
+        <p:nvSpPr>
+          <p:cNvPr id="14" name="Rounded Rectangle 4"/>
+          <p:cNvSpPr/>
+          <p:nvPr/>
+        </p:nvSpPr>
+        <p:spPr>
+          <a:xfrm>
+            <a:off x="594360" y="1417320"/>
+            <a:ext cx="1463040" cy="822960"/>
+          </a:xfrm>
+          <a:prstGeom prst="roundRect">
+            <a:avLst/>
+          </a:prstGeom>
+          <a:solidFill>
+            <a:srgbClr val="F5F9F4"/>
+          </a:solidFill>
+          <a:ln>
+            <a:solidFill>
+              <a:srgbClr val="BFD6C4"/>
+            </a:solidFill>
+          </a:ln>
+        </p:spPr>
+        <p:style>
+          <a:lnRef idx="1">
+            <a:schemeClr val="accent1"/>
+          </a:lnRef>
+          <a:fillRef idx="3">
+            <a:schemeClr val="accent1"/>
+          </a:fillRef>
+          <a:effectRef idx="2">
+            <a:schemeClr val="accent1"/>
+          </a:effectRef>
+          <a:fontRef idx="minor">
+            <a:schemeClr val="lt1"/>
+          </a:fontRef>
+        </p:style>
+        <p:txBody>
+          <a:bodyPr rtlCol="0" anchor="ctr"/>
+          <a:lstStyle/>
+          <a:p>
+            <a:pPr algn="ctr"/>
+            <a:r>
+              <a:rPr sz="2200" b="1">
+                <a:solidFill>
+                  <a:srgbClr val="1F774A"/>
+                </a:solidFill>
+                <a:latin typeface="Aptos"/>
+              </a:rPr>
+              <a:t>93</a:t>
+            </a:r>
+            <a:endParaRPr sz="2200" b="1">
+              <a:solidFill>
+                <a:srgbClr val="1F774A"/>
+              </a:solidFill>
+              <a:latin typeface="Aptos"/>
+            </a:endParaRPr>
+          </a:p>
+          <a:p>
+            <a:pPr algn="ctr"/>
+            <a:r>
+              <a:rPr sz="1100">
+                <a:solidFill>
+                  <a:srgbClr val="5F5F5F"/>
+                </a:solidFill>
+                <a:latin typeface="Aptos"/>
+              </a:rPr>
+              <a:t>Tests</a:t>
+            </a:r>
+            <a:endParaRPr sz="1100">
+              <a:solidFill>
+                <a:srgbClr val="5F5F5F"/>
+              </a:solidFill>
+              <a:latin typeface="Aptos"/>
+            </a:endParaRPr>
+          </a:p>
+        </p:txBody>
+      </p:sp>
+      <p:sp>
+        <p:nvSpPr>
+          <p:cNvPr id="15" name="Rounded Rectangle 5"/>
+          <p:cNvSpPr/>
+          <p:nvPr/>
+        </p:nvSpPr>
+        <p:spPr>
+          <a:xfrm>
+            <a:off x="2240280" y="1417320"/>
+            <a:ext cx="1645920" cy="822960"/>
+          </a:xfrm>
+          <a:prstGeom prst="roundRect">
+            <a:avLst/>
+          </a:prstGeom>
+          <a:solidFill>
+            <a:srgbClr val="F5F9F4"/>
+          </a:solidFill>
+          <a:ln>
+            <a:solidFill>
+              <a:srgbClr val="BFD6C4"/>
+            </a:solidFill>
+          </a:ln>
+        </p:spPr>
+        <p:style>
+          <a:lnRef idx="1">
+            <a:schemeClr val="accent1"/>
+          </a:lnRef>
+          <a:fillRef idx="3">
+            <a:schemeClr val="accent1"/>
+          </a:fillRef>
+          <a:effectRef idx="2">
+            <a:schemeClr val="accent1"/>
+          </a:effectRef>
+          <a:fontRef idx="minor">
+            <a:schemeClr val="lt1"/>
+          </a:fontRef>
+        </p:style>
+        <p:txBody>
+          <a:bodyPr rtlCol="0" anchor="ctr"/>
+          <a:lstStyle/>
+          <a:p>
+            <a:pPr algn="ctr"/>
+            <a:r>
+              <a:rPr sz="2200" b="1">
+                <a:solidFill>
+                  <a:srgbClr val="1F774A"/>
+                </a:solidFill>
+                <a:latin typeface="Aptos"/>
+              </a:rPr>
+              <a:t>0</a:t>
+            </a:r>
+            <a:endParaRPr sz="2200" b="1">
+              <a:solidFill>
+                <a:srgbClr val="1F774A"/>
+              </a:solidFill>
+              <a:latin typeface="Aptos"/>
+            </a:endParaRPr>
+          </a:p>
+          <a:p>
+            <a:pPr algn="ctr"/>
+            <a:r>
+              <a:rPr sz="1100">
+                <a:solidFill>
+                  <a:srgbClr val="5F5F5F"/>
+                </a:solidFill>
+                <a:latin typeface="Aptos"/>
+              </a:rPr>
+              <a:t>Failures</a:t>
+            </a:r>
+            <a:endParaRPr sz="1100">
+              <a:solidFill>
+                <a:srgbClr val="5F5F5F"/>
+              </a:solidFill>
+              <a:latin typeface="Aptos"/>
+            </a:endParaRPr>
+          </a:p>
+        </p:txBody>
+      </p:sp>
+      <p:sp>
+        <p:nvSpPr>
+          <p:cNvPr id="16" name="Rounded Rectangle 6"/>
+          <p:cNvSpPr/>
+          <p:nvPr/>
+        </p:nvSpPr>
+        <p:spPr>
+          <a:xfrm>
+            <a:off x="4069080" y="1417320"/>
+            <a:ext cx="1645920" cy="822960"/>
+          </a:xfrm>
+          <a:prstGeom prst="roundRect">
+            <a:avLst/>
+          </a:prstGeom>
+          <a:solidFill>
+            <a:srgbClr val="F5F9F4"/>
+          </a:solidFill>
+          <a:ln>
+            <a:solidFill>
+              <a:srgbClr val="BFD6C4"/>
+            </a:solidFill>
+          </a:ln>
+        </p:spPr>
+        <p:style>
+          <a:lnRef idx="1">
+            <a:schemeClr val="accent1"/>
+          </a:lnRef>
+          <a:fillRef idx="3">
+            <a:schemeClr val="accent1"/>
+          </a:fillRef>
+          <a:effectRef idx="2">
+            <a:schemeClr val="accent1"/>
+          </a:effectRef>
+          <a:fontRef idx="minor">
+            <a:schemeClr val="lt1"/>
+          </a:fontRef>
+        </p:style>
+        <p:txBody>
+          <a:bodyPr rtlCol="0" anchor="ctr"/>
+          <a:lstStyle/>
+          <a:p>
+            <a:pPr algn="ctr"/>
+            <a:r>
+              <a:rPr sz="2200" b="1">
+                <a:solidFill>
+                  <a:srgbClr val="1F774A"/>
+                </a:solidFill>
+                <a:latin typeface="Aptos"/>
+              </a:rPr>
+              <a:t>0</a:t>
+            </a:r>
+            <a:endParaRPr sz="2200" b="1">
+              <a:solidFill>
+                <a:srgbClr val="1F774A"/>
+              </a:solidFill>
+              <a:latin typeface="Aptos"/>
+            </a:endParaRPr>
+          </a:p>
+          <a:p>
+            <a:pPr algn="ctr"/>
+            <a:r>
+              <a:rPr sz="1100">
+                <a:solidFill>
+                  <a:srgbClr val="5F5F5F"/>
+                </a:solidFill>
+                <a:latin typeface="Aptos"/>
+              </a:rPr>
+              <a:t>Skipped</a:t>
+            </a:r>
+            <a:endParaRPr sz="1100">
+              <a:solidFill>
+                <a:srgbClr val="5F5F5F"/>
+              </a:solidFill>
+              <a:latin typeface="Aptos"/>
+            </a:endParaRPr>
+          </a:p>
+        </p:txBody>
+      </p:sp>
+      <p:sp>
+        <p:nvSpPr>
+          <p:cNvPr id="17" name="Rounded Rectangle 7"/>
+          <p:cNvSpPr/>
+          <p:nvPr/>
+        </p:nvSpPr>
+        <p:spPr>
+          <a:xfrm>
+            <a:off x="5897880" y="1417320"/>
+            <a:ext cx="2011680" cy="822960"/>
+          </a:xfrm>
+          <a:prstGeom prst="roundRect">
+            <a:avLst/>
+          </a:prstGeom>
+          <a:solidFill>
+            <a:srgbClr val="F5F9F4"/>
+          </a:solidFill>
+          <a:ln>
+            <a:solidFill>
+              <a:srgbClr val="BFD6C4"/>
+            </a:solidFill>
+          </a:ln>
+        </p:spPr>
+        <p:style>
+          <a:lnRef idx="1">
+            <a:schemeClr val="accent1"/>
+          </a:lnRef>
+          <a:fillRef idx="3">
+            <a:schemeClr val="accent1"/>
+          </a:fillRef>
+          <a:effectRef idx="2">
+            <a:schemeClr val="accent1"/>
+          </a:effectRef>
+          <a:fontRef idx="minor">
+            <a:schemeClr val="lt1"/>
+          </a:fontRef>
+        </p:style>
+        <p:txBody>
+          <a:bodyPr rtlCol="0" anchor="ctr"/>
+          <a:lstStyle/>
+          <a:p>
+            <a:pPr algn="ctr"/>
+            <a:r>
+              <a:rPr sz="2200" b="1">
+                <a:solidFill>
+                  <a:srgbClr val="1F774A"/>
+                </a:solidFill>
+                <a:latin typeface="Aptos"/>
+              </a:rPr>
+              <a:t>6</a:t>
+            </a:r>
+            <a:endParaRPr sz="2200" b="1">
+              <a:solidFill>
+                <a:srgbClr val="1F774A"/>
+              </a:solidFill>
+              <a:latin typeface="Aptos"/>
+            </a:endParaRPr>
+          </a:p>
+          <a:p>
+            <a:pPr algn="ctr"/>
+            <a:r>
+              <a:rPr sz="1100">
+                <a:solidFill>
+                  <a:srgbClr val="5F5F5F"/>
+                </a:solidFill>
+                <a:latin typeface="Aptos"/>
+              </a:rPr>
+              <a:t>Test Files</a:t>
+            </a:r>
+            <a:endParaRPr sz="1100">
+              <a:solidFill>
+                <a:srgbClr val="5F5F5F"/>
+              </a:solidFill>
+              <a:latin typeface="Aptos"/>
+            </a:endParaRPr>
+          </a:p>
+        </p:txBody>
+      </p:sp>
+      <p:sp>
+        <p:nvSpPr>
+          <p:cNvPr id="18" name="Rounded Rectangle 8"/>
+          <p:cNvSpPr/>
+          <p:nvPr/>
+        </p:nvSpPr>
+        <p:spPr>
+          <a:xfrm>
+            <a:off x="8138160" y="1417320"/>
+            <a:ext cx="1828800" cy="822960"/>
+          </a:xfrm>
+          <a:prstGeom prst="roundRect">
+            <a:avLst/>
+          </a:prstGeom>
+          <a:solidFill>
+            <a:srgbClr val="F5F9F4"/>
+          </a:solidFill>
+          <a:ln>
+            <a:solidFill>
+              <a:srgbClr val="BFD6C4"/>
+            </a:solidFill>
+          </a:ln>
+        </p:spPr>
+        <p:style>
+          <a:lnRef idx="1">
+            <a:schemeClr val="accent1"/>
+          </a:lnRef>
+          <a:fillRef idx="3">
+            <a:schemeClr val="accent1"/>
+          </a:fillRef>
+          <a:effectRef idx="2">
+            <a:schemeClr val="accent1"/>
+          </a:effectRef>
+          <a:fontRef idx="minor">
+            <a:schemeClr val="lt1"/>
+          </a:fontRef>
+        </p:style>
+        <p:txBody>
+          <a:bodyPr rtlCol="0" anchor="ctr"/>
+          <a:lstStyle/>
+          <a:p>
+            <a:pPr algn="ctr"/>
+            <a:r>
+              <a:rPr sz="2200" b="1">
+                <a:solidFill>
+                  <a:srgbClr val="1F774A"/>
+                </a:solidFill>
+                <a:latin typeface="Aptos"/>
+              </a:rPr>
+              <a:t>5m 04s</a:t>
+            </a:r>
+            <a:endParaRPr sz="2200" b="1">
+              <a:solidFill>
+                <a:srgbClr val="1F774A"/>
+              </a:solidFill>
+              <a:latin typeface="Aptos"/>
+            </a:endParaRPr>
+          </a:p>
+          <a:p>
+            <a:pPr algn="ctr"/>
+            <a:r>
+              <a:rPr sz="1100">
+                <a:solidFill>
+                  <a:srgbClr val="5F5F5F"/>
+                </a:solidFill>
+                <a:latin typeface="Aptos"/>
+              </a:rPr>
+              <a:t>Runtime</a:t>
+            </a:r>
+            <a:endParaRPr sz="1100">
+              <a:solidFill>
+                <a:srgbClr val="5F5F5F"/>
+              </a:solidFill>
+              <a:latin typeface="Aptos"/>
+            </a:endParaRPr>
+          </a:p>
+        </p:txBody>
+      </p:sp>
+      <p:sp>
+        <p:nvSpPr>
+          <p:cNvPr id="19" name="Rounded Rectangle 9"/>
+          <p:cNvSpPr/>
+          <p:nvPr/>
+        </p:nvSpPr>
+        <p:spPr>
+          <a:xfrm>
+            <a:off x="594360" y="2514600"/>
+            <a:ext cx="5349240" cy="3611880"/>
+          </a:xfrm>
+          <a:prstGeom prst="roundRect">
+            <a:avLst/>
+          </a:prstGeom>
+          <a:solidFill>
+            <a:srgbClr val="EBF2FA"/>
+          </a:solidFill>
+          <a:ln w="15240">
+            <a:solidFill>
+              <a:srgbClr val="B4C2D6"/>
+            </a:solidFill>
+          </a:ln>
+        </p:spPr>
+        <p:style>
+          <a:lnRef idx="1">
+            <a:schemeClr val="accent1"/>
+          </a:lnRef>
+          <a:fillRef idx="3">
+            <a:schemeClr val="accent1"/>
+          </a:fillRef>
+          <a:effectRef idx="2">
+            <a:schemeClr val="accent1"/>
+          </a:effectRef>
+          <a:fontRef idx="minor">
+            <a:schemeClr val="lt1"/>
+          </a:fontRef>
+        </p:style>
+        <p:txBody>
+          <a:bodyPr wrap="square" rtlCol="0" anchor="ctr"/>
+          <a:lstStyle/>
+          <a:p>
+            <a:pPr algn="ctr"/>
+            <a:r>
+              <a:rPr sz="1500" b="1">
+                <a:solidFill>
+                  <a:srgbClr val="2E5488"/>
+                </a:solidFill>
+                <a:latin typeface="Aptos"/>
+              </a:rPr>
+              <a:t>Coverage Areas</a:t>
+            </a:r>
+            <a:endParaRPr sz="1500" b="1">
+              <a:solidFill>
+                <a:srgbClr val="2E5488"/>
+              </a:solidFill>
+              <a:latin typeface="Aptos"/>
+            </a:endParaRPr>
+          </a:p>
+          <a:p>
+            <a:pPr>
+              <a:defRPr sz="1100">
+                <a:solidFill>
+                  <a:srgbClr val="282828"/>
+                </a:solidFill>
+                <a:latin typeface="Aptos"/>
+              </a:defRPr>
+            </a:pPr>
+            <a:r>
+              <a:t>observe_schema: schema correctness, PK/FK metadata, custom tables, authentication failure paths</a:t>
+            </a:r>
+          </a:p>
+          <a:p>
+            <a:pPr>
+              <a:defRPr sz="1100">
+                <a:solidFill>
+                  <a:srgbClr val="282828"/>
+                </a:solidFill>
+                <a:latin typeface="Aptos"/>
+              </a:defRPr>
+            </a:pPr>
+            <a:r>
+              <a:t>run_python_analysis: allowed execution, forbidden imports/calls, SQL filtering, syntax/runtime errors, timeout handling</a:t>
+            </a:r>
+          </a:p>
+          <a:p>
+            <a:pPr>
+              <a:defRPr sz="1100">
+                <a:solidFill>
+                  <a:srgbClr val="282828"/>
+                </a:solidFill>
+                <a:latin typeface="Aptos"/>
+              </a:defRPr>
+            </a:pPr>
+            <a:r>
+              <a:t>saved_queries CRUD: create, read, update, delete, 404/401/422 validation paths</a:t>
+            </a:r>
+          </a:p>
+          <a:p>
+            <a:pPr>
+              <a:defRPr sz="1100">
+                <a:solidFill>
+                  <a:srgbClr val="282828"/>
+                </a:solidFill>
+                <a:latin typeface="Aptos"/>
+              </a:defRPr>
+            </a:pPr>
+            <a:r>
+              <a:t>negative API tests: employees, products, analytics, logs, invalid parameters and missing resources</a:t>
+            </a:r>
+          </a:p>
+        </p:txBody>
+      </p:sp>
+      <p:sp>
+        <p:nvSpPr>
+          <p:cNvPr id="20" name="Rounded Rectangle 10"/>
+          <p:cNvSpPr/>
+          <p:nvPr/>
+        </p:nvSpPr>
+        <p:spPr>
+          <a:xfrm>
+            <a:off x="6172200" y="2514600"/>
+            <a:ext cx="5394960" cy="3611880"/>
+          </a:xfrm>
+          <a:prstGeom prst="roundRect">
+            <a:avLst/>
+          </a:prstGeom>
+          <a:solidFill>
+            <a:srgbClr val="EBF2FA"/>
+          </a:solidFill>
+          <a:ln w="15240">
+            <a:solidFill>
+              <a:srgbClr val="B4C2D6"/>
+            </a:solidFill>
+          </a:ln>
+        </p:spPr>
+        <p:style>
+          <a:lnRef idx="1">
+            <a:schemeClr val="accent1"/>
+          </a:lnRef>
+          <a:fillRef idx="3">
+            <a:schemeClr val="accent1"/>
+          </a:fillRef>
+          <a:effectRef idx="2">
+            <a:schemeClr val="accent1"/>
+          </a:effectRef>
+          <a:fontRef idx="minor">
+            <a:schemeClr val="lt1"/>
+          </a:fontRef>
+        </p:style>
+        <p:txBody>
+          <a:bodyPr wrap="square" rtlCol="0" anchor="ctr"/>
+          <a:lstStyle/>
+          <a:p>
+            <a:pPr algn="ctr"/>
+            <a:r>
+              <a:rPr sz="1500" b="1">
+                <a:solidFill>
+                  <a:srgbClr val="2E5488"/>
+                </a:solidFill>
+                <a:latin typeface="Aptos"/>
+              </a:rPr>
+              <a:t>Higher-Value Evidence</a:t>
+            </a:r>
+            <a:endParaRPr sz="1500" b="1">
+              <a:solidFill>
+                <a:srgbClr val="2E5488"/>
+              </a:solidFill>
+              <a:latin typeface="Aptos"/>
+            </a:endParaRPr>
+          </a:p>
+          <a:p>
+            <a:pPr>
+              <a:defRPr sz="1100">
+                <a:solidFill>
+                  <a:srgbClr val="282828"/>
+                </a:solidFill>
+                <a:latin typeface="Aptos"/>
+              </a:defRPr>
+            </a:pPr>
+            <a:r>
+              <a:t>Multistep agent tests verify schema-first behaviour and tool_trace ordering</a:t>
+            </a:r>
+          </a:p>
+          <a:p>
+            <a:pPr>
+              <a:defRPr sz="1100">
+                <a:solidFill>
+                  <a:srgbClr val="282828"/>
+                </a:solidFill>
+                <a:latin typeface="Aptos"/>
+              </a:defRPr>
+            </a:pPr>
+            <a:r>
+              <a:t>Security tests show jailbreak attempts are blocked rather than silently ignored</a:t>
+            </a:r>
+          </a:p>
+          <a:p>
+            <a:pPr>
+              <a:defRPr sz="1100">
+                <a:solidFill>
+                  <a:srgbClr val="282828"/>
+                </a:solidFill>
+                <a:latin typeface="Aptos"/>
+              </a:defRPr>
+            </a:pPr>
+            <a:r>
+              <a:t>Anomaly-detection tests validate domain reasoning over real business data</a:t>
+            </a:r>
+          </a:p>
+          <a:p>
+            <a:pPr>
+              <a:defRPr sz="1100">
+                <a:solidFill>
+                  <a:srgbClr val="282828"/>
+                </a:solidFill>
+                <a:latin typeface="Aptos"/>
+              </a:defRPr>
+            </a:pPr>
+            <a:r>
+              <a:t>End-to-end runs prove the LLM layer is grounded in tool outputs, not hard-coded answers</a:t>
+            </a:r>
+          </a:p>
+        </p:txBody>
+      </p:sp>
+    </p:spTree>
+  </p:cSld>
+  <p:clrMapOvr>
+    <a:masterClrMapping/>
+  </p:clrMapOvr>
+</p:sld>
+</file>
+
+<file path=ppt/slides/slide12.xml><?xml version="1.0" encoding="utf-8"?>
+<p:sld xmlns:a="http://schemas.openxmlformats.org/drawingml/2006/main" xmlns:r="http://schemas.openxmlformats.org/officeDocument/2006/relationships" xmlns:p="http://schemas.openxmlformats.org/presentationml/2006/main">
+  <p:cSld>
+    <p:spTree>
+      <p:nvGrpSpPr>
+        <p:cNvPr id="1" name=""/>
+        <p:cNvGrpSpPr/>
+        <p:nvPr/>
+      </p:nvGrpSpPr>
+      <p:grpSpPr>
+        <a:xfrm>
+          <a:off x="0" y="0"/>
+          <a:ext cx="0" cy="0"/>
+          <a:chOff x="0" y="0"/>
+          <a:chExt cx="0" cy="0"/>
+        </a:xfrm>
+      </p:grpSpPr>
+      <p:sp>
+        <p:nvSpPr>
+          <p:cNvPr id="2" name="Text 0"/>
+          <p:cNvSpPr/>
+          <p:nvPr/>
+        </p:nvSpPr>
+        <p:spPr>
+          <a:xfrm>
+            <a:off x="502920" y="347472"/>
+            <a:ext cx="7863840" cy="411480"/>
+          </a:xfrm>
+          <a:prstGeom prst="rect">
+            <a:avLst/>
+          </a:prstGeom>
+          <a:noFill/>
+        </p:spPr>
+        <p:txBody>
+          <a:bodyPr wrap="square" lIns="0" tIns="0" rIns="0" bIns="0" rtlCol="0" anchor="ctr"/>
+          <a:lstStyle/>
+          <a:p>
+            <a:pPr marL="0" indent="0">
+              <a:buNone/>
+            </a:pPr>
+            <a:r>
+              <a:rPr sz="2400" b="1">
+                <a:solidFill>
+                  <a:srgbClr val="282828"/>
+                </a:solidFill>
+                <a:latin typeface="Aptos"/>
+                <a:sym typeface="+mn-ea"/>
+              </a:rPr>
+              <a:t>Test Breakdown</a:t>
+            </a:r>
+            <a:endParaRPr lang="en-US" sz="2400" dirty="0"/>
+          </a:p>
+        </p:txBody>
+      </p:sp>
+      <p:sp>
+        <p:nvSpPr>
+          <p:cNvPr id="3" name="Text 1"/>
+          <p:cNvSpPr/>
+          <p:nvPr/>
+        </p:nvSpPr>
+        <p:spPr>
+          <a:xfrm>
+            <a:off x="530352" y="804672"/>
+            <a:ext cx="10789920" cy="274320"/>
+          </a:xfrm>
+          <a:prstGeom prst="rect">
+            <a:avLst/>
+          </a:prstGeom>
+          <a:noFill/>
+        </p:spPr>
+        <p:txBody>
+          <a:bodyPr wrap="square" lIns="0" tIns="0" rIns="0" bIns="0" rtlCol="0" anchor="ctr"/>
+          <a:lstStyle/>
+          <a:p>
+            <a:pPr marL="0" indent="0">
+              <a:buNone/>
+            </a:pPr>
+            <a:r>
+              <a:rPr sz="1100">
+                <a:solidFill>
+                  <a:srgbClr val="5F5F5F"/>
+                </a:solidFill>
+                <a:latin typeface="Aptos"/>
+                <a:sym typeface="+mn-ea"/>
+              </a:rPr>
+              <a:t>93/93 tests passed in 5m 04s, covering security checks, CRUD, negative API cases, multistep agent reasoning, and anomaly detection.</a:t>
+            </a:r>
+            <a:endParaRPr lang="en-US" sz="1100" dirty="0"/>
+          </a:p>
+        </p:txBody>
+      </p:sp>
+      <p:sp>
+        <p:nvSpPr>
+          <p:cNvPr id="25" name="Slide Number Placeholder 0"/>
+          <p:cNvSpPr>
+            <a:spLocks noGrp="1"/>
+          </p:cNvSpPr>
+          <p:nvPr>
+            <p:ph type="sldNum" sz="quarter" idx="4294967295"/>
+          </p:nvPr>
+        </p:nvSpPr>
+        <p:spPr>
+          <a:xfrm>
+            <a:off x="11567160" y="6473825"/>
+            <a:ext cx="407035" cy="182880"/>
+          </a:xfrm>
+          <a:prstGeom prst="rect">
+            <a:avLst/>
+          </a:prstGeom>
+        </p:spPr>
+        <p:txBody>
+          <a:bodyPr/>
+          <a:lstStyle>
+            <a:lvl1pPr>
+              <a:defRPr sz="1000">
+                <a:solidFill>
+                  <a:srgbClr val="64748B"/>
+                </a:solidFill>
+                <a:latin typeface="Aptos"/>
+                <a:ea typeface="Aptos"/>
+                <a:cs typeface="Aptos"/>
+              </a:defRPr>
+            </a:lvl1pPr>
+          </a:lstStyle>
+          <a:p>
+            <a:pPr algn="ctr"/>
+            <a:fld id="{F7021451-1387-4CA6-816F-3879F97B5CBC}" type="slidenum">
+              <a:rPr lang="en-US" b="0"/>
+            </a:fld>
+            <a:endParaRPr lang="en-US"/>
+          </a:p>
+        </p:txBody>
+      </p:sp>
+      <p:sp>
+        <p:nvSpPr>
+          <p:cNvPr id="4" name="Rectangle 3"/>
+          <p:cNvSpPr/>
+          <p:nvPr/>
+        </p:nvSpPr>
+        <p:spPr>
+          <a:xfrm>
+            <a:off x="594360" y="1234440"/>
+            <a:ext cx="3017520" cy="411480"/>
+          </a:xfrm>
+          <a:prstGeom prst="rect">
+            <a:avLst/>
+          </a:prstGeom>
+          <a:solidFill>
+            <a:srgbClr val="2E5488"/>
+          </a:solidFill>
+          <a:ln>
+            <a:solidFill>
+              <a:srgbClr val="2E5488"/>
+            </a:solidFill>
+          </a:ln>
+        </p:spPr>
+        <p:style>
+          <a:lnRef idx="1">
+            <a:schemeClr val="accent1"/>
+          </a:lnRef>
+          <a:fillRef idx="3">
+            <a:schemeClr val="accent1"/>
+          </a:fillRef>
+          <a:effectRef idx="2">
+            <a:schemeClr val="accent1"/>
+          </a:effectRef>
+          <a:fontRef idx="minor">
+            <a:schemeClr val="lt1"/>
+          </a:fontRef>
+        </p:style>
+        <p:txBody>
+          <a:bodyPr rtlCol="0" anchor="ctr"/>
+          <a:lstStyle/>
+          <a:p>
+            <a:pPr algn="ctr"/>
+            <a:r>
+              <a:rPr sz="1200" b="1">
+                <a:solidFill>
+                  <a:srgbClr val="FFFFFF"/>
+                </a:solidFill>
+                <a:latin typeface="Aptos"/>
+              </a:rPr>
+              <a:t>File</a:t>
+            </a:r>
+            <a:endParaRPr sz="1200" b="1">
+              <a:solidFill>
+                <a:srgbClr val="FFFFFF"/>
+              </a:solidFill>
+              <a:latin typeface="Aptos"/>
+            </a:endParaRPr>
+          </a:p>
+        </p:txBody>
+      </p:sp>
+      <p:sp>
+        <p:nvSpPr>
+          <p:cNvPr id="5" name="Rectangle 4"/>
+          <p:cNvSpPr/>
+          <p:nvPr/>
+        </p:nvSpPr>
+        <p:spPr>
+          <a:xfrm>
+            <a:off x="3794760" y="1234440"/>
+            <a:ext cx="731520" cy="411480"/>
+          </a:xfrm>
+          <a:prstGeom prst="rect">
+            <a:avLst/>
+          </a:prstGeom>
+          <a:solidFill>
+            <a:srgbClr val="2E5488"/>
+          </a:solidFill>
+          <a:ln>
+            <a:solidFill>
+              <a:srgbClr val="2E5488"/>
+            </a:solidFill>
+          </a:ln>
+        </p:spPr>
+        <p:style>
+          <a:lnRef idx="1">
+            <a:schemeClr val="accent1"/>
+          </a:lnRef>
+          <a:fillRef idx="3">
+            <a:schemeClr val="accent1"/>
+          </a:fillRef>
+          <a:effectRef idx="2">
+            <a:schemeClr val="accent1"/>
+          </a:effectRef>
+          <a:fontRef idx="minor">
+            <a:schemeClr val="lt1"/>
+          </a:fontRef>
+        </p:style>
+        <p:txBody>
+          <a:bodyPr rtlCol="0" anchor="ctr"/>
+          <a:lstStyle/>
+          <a:p>
+            <a:pPr algn="ctr"/>
+            <a:r>
+              <a:rPr sz="1200" b="1">
+                <a:solidFill>
+                  <a:srgbClr val="FFFFFF"/>
+                </a:solidFill>
+                <a:latin typeface="Aptos"/>
+              </a:rPr>
+              <a:t>Tests</a:t>
+            </a:r>
+            <a:endParaRPr sz="1200" b="1">
+              <a:solidFill>
+                <a:srgbClr val="FFFFFF"/>
+              </a:solidFill>
+              <a:latin typeface="Aptos"/>
+            </a:endParaRPr>
+          </a:p>
+        </p:txBody>
+      </p:sp>
+      <p:sp>
+        <p:nvSpPr>
+          <p:cNvPr id="6" name="Rectangle 5"/>
+          <p:cNvSpPr/>
+          <p:nvPr/>
+        </p:nvSpPr>
+        <p:spPr>
+          <a:xfrm>
+            <a:off x="4709160" y="1234440"/>
+            <a:ext cx="6812280" cy="411480"/>
+          </a:xfrm>
+          <a:prstGeom prst="rect">
+            <a:avLst/>
+          </a:prstGeom>
+          <a:solidFill>
+            <a:srgbClr val="2E5488"/>
+          </a:solidFill>
+          <a:ln>
+            <a:solidFill>
+              <a:srgbClr val="2E5488"/>
+            </a:solidFill>
+          </a:ln>
+        </p:spPr>
+        <p:style>
+          <a:lnRef idx="1">
+            <a:schemeClr val="accent1"/>
+          </a:lnRef>
+          <a:fillRef idx="3">
+            <a:schemeClr val="accent1"/>
+          </a:fillRef>
+          <a:effectRef idx="2">
+            <a:schemeClr val="accent1"/>
+          </a:effectRef>
+          <a:fontRef idx="minor">
+            <a:schemeClr val="lt1"/>
+          </a:fontRef>
+        </p:style>
+        <p:txBody>
+          <a:bodyPr rtlCol="0" anchor="ctr"/>
+          <a:lstStyle/>
+          <a:p>
+            <a:pPr algn="ctr"/>
+            <a:r>
+              <a:rPr sz="1200" b="1">
+                <a:solidFill>
+                  <a:srgbClr val="FFFFFF"/>
+                </a:solidFill>
+                <a:latin typeface="Aptos"/>
+              </a:rPr>
+              <a:t>What it validates</a:t>
+            </a:r>
+            <a:endParaRPr sz="1200" b="1">
+              <a:solidFill>
+                <a:srgbClr val="FFFFFF"/>
+              </a:solidFill>
+              <a:latin typeface="Aptos"/>
+            </a:endParaRPr>
+          </a:p>
+        </p:txBody>
+      </p:sp>
+      <p:sp>
+        <p:nvSpPr>
+          <p:cNvPr id="7" name="Rectangle 6"/>
+          <p:cNvSpPr/>
+          <p:nvPr/>
+        </p:nvSpPr>
+        <p:spPr>
+          <a:xfrm>
+            <a:off x="594360" y="1664208"/>
+            <a:ext cx="3017520" cy="658368"/>
+          </a:xfrm>
+          <a:prstGeom prst="rect">
+            <a:avLst/>
+          </a:prstGeom>
+          <a:solidFill>
+            <a:srgbClr val="F8FAFD"/>
+          </a:solidFill>
+          <a:ln>
+            <a:solidFill>
+              <a:srgbClr val="B4C2D6"/>
+            </a:solidFill>
+          </a:ln>
+        </p:spPr>
+        <p:style>
+          <a:lnRef idx="1">
+            <a:schemeClr val="accent1"/>
+          </a:lnRef>
+          <a:fillRef idx="3">
+            <a:schemeClr val="accent1"/>
+          </a:fillRef>
+          <a:effectRef idx="2">
+            <a:schemeClr val="accent1"/>
+          </a:effectRef>
+          <a:fontRef idx="minor">
+            <a:schemeClr val="lt1"/>
+          </a:fontRef>
+        </p:style>
+        <p:txBody>
+          <a:bodyPr wrap="square" rtlCol="0" anchor="ctr"/>
+          <a:lstStyle/>
+          <a:p>
+            <a:pPr algn="l"/>
+            <a:r>
+              <a:rPr sz="1050" b="1">
+                <a:solidFill>
+                  <a:srgbClr val="282828"/>
+                </a:solidFill>
+                <a:latin typeface="Aptos"/>
+              </a:rPr>
+              <a:t>test_observe_schema.py</a:t>
+            </a:r>
+            <a:endParaRPr sz="1050" b="1">
+              <a:solidFill>
+                <a:srgbClr val="282828"/>
+              </a:solidFill>
+              <a:latin typeface="Aptos"/>
+            </a:endParaRPr>
+          </a:p>
+        </p:txBody>
+      </p:sp>
+      <p:sp>
+        <p:nvSpPr>
+          <p:cNvPr id="8" name="Rectangle 7"/>
+          <p:cNvSpPr/>
+          <p:nvPr/>
+        </p:nvSpPr>
+        <p:spPr>
+          <a:xfrm>
+            <a:off x="3794760" y="1664208"/>
+            <a:ext cx="731520" cy="658368"/>
+          </a:xfrm>
+          <a:prstGeom prst="rect">
+            <a:avLst/>
+          </a:prstGeom>
+          <a:solidFill>
+            <a:srgbClr val="F8FAFD"/>
+          </a:solidFill>
+          <a:ln>
+            <a:solidFill>
+              <a:srgbClr val="B4C2D6"/>
+            </a:solidFill>
+          </a:ln>
+        </p:spPr>
+        <p:style>
+          <a:lnRef idx="1">
+            <a:schemeClr val="accent1"/>
+          </a:lnRef>
+          <a:fillRef idx="3">
+            <a:schemeClr val="accent1"/>
+          </a:fillRef>
+          <a:effectRef idx="2">
+            <a:schemeClr val="accent1"/>
+          </a:effectRef>
+          <a:fontRef idx="minor">
+            <a:schemeClr val="lt1"/>
+          </a:fontRef>
+        </p:style>
+        <p:txBody>
+          <a:bodyPr wrap="square" rtlCol="0" anchor="ctr"/>
+          <a:lstStyle/>
+          <a:p>
+            <a:pPr algn="ctr"/>
+            <a:r>
+              <a:rPr sz="1050">
+                <a:solidFill>
+                  <a:srgbClr val="282828"/>
+                </a:solidFill>
+                <a:latin typeface="Aptos"/>
+              </a:rPr>
+              <a:t>10</a:t>
+            </a:r>
+            <a:endParaRPr sz="1050">
+              <a:solidFill>
+                <a:srgbClr val="282828"/>
+              </a:solidFill>
+              <a:latin typeface="Aptos"/>
+            </a:endParaRPr>
+          </a:p>
+        </p:txBody>
+      </p:sp>
+      <p:sp>
+        <p:nvSpPr>
+          <p:cNvPr id="9" name="Rectangle 8"/>
+          <p:cNvSpPr/>
+          <p:nvPr/>
+        </p:nvSpPr>
+        <p:spPr>
+          <a:xfrm>
+            <a:off x="4709160" y="1664208"/>
+            <a:ext cx="6812280" cy="658368"/>
+          </a:xfrm>
+          <a:prstGeom prst="rect">
+            <a:avLst/>
+          </a:prstGeom>
+          <a:solidFill>
+            <a:srgbClr val="F8FAFD"/>
+          </a:solidFill>
+          <a:ln>
+            <a:solidFill>
+              <a:srgbClr val="B4C2D6"/>
+            </a:solidFill>
+          </a:ln>
+        </p:spPr>
+        <p:style>
+          <a:lnRef idx="1">
+            <a:schemeClr val="accent1"/>
+          </a:lnRef>
+          <a:fillRef idx="3">
+            <a:schemeClr val="accent1"/>
+          </a:fillRef>
+          <a:effectRef idx="2">
+            <a:schemeClr val="accent1"/>
+          </a:effectRef>
+          <a:fontRef idx="minor">
+            <a:schemeClr val="lt1"/>
+          </a:fontRef>
+        </p:style>
+        <p:txBody>
+          <a:bodyPr wrap="square" rtlCol="0" anchor="ctr"/>
+          <a:lstStyle/>
+          <a:p>
+            <a:pPr algn="l"/>
+            <a:r>
+              <a:rPr sz="1000">
+                <a:solidFill>
+                  <a:srgbClr val="282828"/>
+                </a:solidFill>
+                <a:latin typeface="Aptos"/>
+              </a:rPr>
+              <a:t>Schema structure, business tables, PK/FK metadata, custom tables, auth failures</a:t>
+            </a:r>
+            <a:endParaRPr sz="1000">
+              <a:solidFill>
+                <a:srgbClr val="282828"/>
+              </a:solidFill>
+              <a:latin typeface="Aptos"/>
+            </a:endParaRPr>
+          </a:p>
+        </p:txBody>
+      </p:sp>
+      <p:sp>
+        <p:nvSpPr>
+          <p:cNvPr id="10" name="Rectangle 9"/>
+          <p:cNvSpPr/>
+          <p:nvPr/>
+        </p:nvSpPr>
+        <p:spPr>
+          <a:xfrm>
+            <a:off x="594360" y="2322576"/>
+            <a:ext cx="3017520" cy="658368"/>
+          </a:xfrm>
+          <a:prstGeom prst="rect">
+            <a:avLst/>
+          </a:prstGeom>
+          <a:solidFill>
+            <a:srgbClr val="EFF4FA"/>
+          </a:solidFill>
+          <a:ln>
+            <a:solidFill>
+              <a:srgbClr val="B4C2D6"/>
+            </a:solidFill>
+          </a:ln>
+        </p:spPr>
+        <p:style>
+          <a:lnRef idx="1">
+            <a:schemeClr val="accent1"/>
+          </a:lnRef>
+          <a:fillRef idx="3">
+            <a:schemeClr val="accent1"/>
+          </a:fillRef>
+          <a:effectRef idx="2">
+            <a:schemeClr val="accent1"/>
+          </a:effectRef>
+          <a:fontRef idx="minor">
+            <a:schemeClr val="lt1"/>
+          </a:fontRef>
+        </p:style>
+        <p:txBody>
+          <a:bodyPr wrap="square" rtlCol="0" anchor="ctr"/>
+          <a:lstStyle/>
+          <a:p>
+            <a:pPr algn="l"/>
+            <a:r>
+              <a:rPr sz="1050" b="1">
+                <a:solidFill>
+                  <a:srgbClr val="282828"/>
+                </a:solidFill>
+                <a:latin typeface="Aptos"/>
+              </a:rPr>
+              <a:t>test_run_python_analysis.py</a:t>
+            </a:r>
+            <a:endParaRPr sz="1050" b="1">
+              <a:solidFill>
+                <a:srgbClr val="282828"/>
+              </a:solidFill>
+              <a:latin typeface="Aptos"/>
+            </a:endParaRPr>
+          </a:p>
+        </p:txBody>
+      </p:sp>
+      <p:sp>
+        <p:nvSpPr>
+          <p:cNvPr id="11" name="Rectangle 10"/>
+          <p:cNvSpPr/>
+          <p:nvPr/>
+        </p:nvSpPr>
+        <p:spPr>
+          <a:xfrm>
+            <a:off x="3794760" y="2322576"/>
+            <a:ext cx="731520" cy="658368"/>
+          </a:xfrm>
+          <a:prstGeom prst="rect">
+            <a:avLst/>
+          </a:prstGeom>
+          <a:solidFill>
+            <a:srgbClr val="EFF4FA"/>
+          </a:solidFill>
+          <a:ln>
+            <a:solidFill>
+              <a:srgbClr val="B4C2D6"/>
+            </a:solidFill>
+          </a:ln>
+        </p:spPr>
+        <p:style>
+          <a:lnRef idx="1">
+            <a:schemeClr val="accent1"/>
+          </a:lnRef>
+          <a:fillRef idx="3">
+            <a:schemeClr val="accent1"/>
+          </a:fillRef>
+          <a:effectRef idx="2">
+            <a:schemeClr val="accent1"/>
+          </a:effectRef>
+          <a:fontRef idx="minor">
+            <a:schemeClr val="lt1"/>
+          </a:fontRef>
+        </p:style>
+        <p:txBody>
+          <a:bodyPr wrap="square" rtlCol="0" anchor="ctr"/>
+          <a:lstStyle/>
+          <a:p>
+            <a:pPr algn="ctr"/>
+            <a:r>
+              <a:rPr sz="1050">
+                <a:solidFill>
+                  <a:srgbClr val="282828"/>
+                </a:solidFill>
+                <a:latin typeface="Aptos"/>
+              </a:rPr>
+              <a:t>20</a:t>
+            </a:r>
+            <a:endParaRPr sz="1050">
+              <a:solidFill>
+                <a:srgbClr val="282828"/>
+              </a:solidFill>
+              <a:latin typeface="Aptos"/>
+            </a:endParaRPr>
+          </a:p>
+        </p:txBody>
+      </p:sp>
+      <p:sp>
+        <p:nvSpPr>
+          <p:cNvPr id="12" name="Rectangle 11"/>
+          <p:cNvSpPr/>
+          <p:nvPr/>
+        </p:nvSpPr>
+        <p:spPr>
+          <a:xfrm>
+            <a:off x="4709160" y="2322576"/>
+            <a:ext cx="6812280" cy="658368"/>
+          </a:xfrm>
+          <a:prstGeom prst="rect">
+            <a:avLst/>
+          </a:prstGeom>
+          <a:solidFill>
+            <a:srgbClr val="EFF4FA"/>
+          </a:solidFill>
+          <a:ln>
+            <a:solidFill>
+              <a:srgbClr val="B4C2D6"/>
+            </a:solidFill>
+          </a:ln>
+        </p:spPr>
+        <p:style>
+          <a:lnRef idx="1">
+            <a:schemeClr val="accent1"/>
+          </a:lnRef>
+          <a:fillRef idx="3">
+            <a:schemeClr val="accent1"/>
+          </a:fillRef>
+          <a:effectRef idx="2">
+            <a:schemeClr val="accent1"/>
+          </a:effectRef>
+          <a:fontRef idx="minor">
+            <a:schemeClr val="lt1"/>
+          </a:fontRef>
+        </p:style>
+        <p:txBody>
+          <a:bodyPr wrap="square" rtlCol="0" anchor="ctr"/>
+          <a:lstStyle/>
+          <a:p>
+            <a:pPr algn="l"/>
+            <a:r>
+              <a:rPr sz="1000">
+                <a:solidFill>
+                  <a:srgbClr val="282828"/>
+                </a:solidFill>
+                <a:latin typeface="Aptos"/>
+              </a:rPr>
+              <a:t>Sandbox success path, forbidden imports/calls, SQL blocks, syntax/runtime errors, timeout handling</a:t>
+            </a:r>
+            <a:endParaRPr sz="1000">
+              <a:solidFill>
+                <a:srgbClr val="282828"/>
+              </a:solidFill>
+              <a:latin typeface="Aptos"/>
+            </a:endParaRPr>
+          </a:p>
+        </p:txBody>
+      </p:sp>
+      <p:sp>
+        <p:nvSpPr>
+          <p:cNvPr id="13" name="Rectangle 12"/>
+          <p:cNvSpPr/>
+          <p:nvPr/>
+        </p:nvSpPr>
+        <p:spPr>
+          <a:xfrm>
+            <a:off x="594360" y="2980944"/>
+            <a:ext cx="3017520" cy="658368"/>
+          </a:xfrm>
+          <a:prstGeom prst="rect">
+            <a:avLst/>
+          </a:prstGeom>
+          <a:solidFill>
+            <a:srgbClr val="F8FAFD"/>
+          </a:solidFill>
+          <a:ln>
+            <a:solidFill>
+              <a:srgbClr val="B4C2D6"/>
+            </a:solidFill>
+          </a:ln>
+        </p:spPr>
+        <p:style>
+          <a:lnRef idx="1">
+            <a:schemeClr val="accent1"/>
+          </a:lnRef>
+          <a:fillRef idx="3">
+            <a:schemeClr val="accent1"/>
+          </a:fillRef>
+          <a:effectRef idx="2">
+            <a:schemeClr val="accent1"/>
+          </a:effectRef>
+          <a:fontRef idx="minor">
+            <a:schemeClr val="lt1"/>
+          </a:fontRef>
+        </p:style>
+        <p:txBody>
+          <a:bodyPr wrap="square" rtlCol="0" anchor="ctr"/>
+          <a:lstStyle/>
+          <a:p>
+            <a:pPr algn="l"/>
+            <a:r>
+              <a:rPr sz="1050" b="1">
+                <a:solidFill>
+                  <a:srgbClr val="282828"/>
+                </a:solidFill>
+                <a:latin typeface="Aptos"/>
+              </a:rPr>
+              <a:t>test_saved_queries.py</a:t>
+            </a:r>
+            <a:endParaRPr sz="1050" b="1">
+              <a:solidFill>
+                <a:srgbClr val="282828"/>
+              </a:solidFill>
+              <a:latin typeface="Aptos"/>
+            </a:endParaRPr>
+          </a:p>
+        </p:txBody>
+      </p:sp>
+      <p:sp>
+        <p:nvSpPr>
+          <p:cNvPr id="21" name="Rectangle 13"/>
+          <p:cNvSpPr/>
+          <p:nvPr/>
+        </p:nvSpPr>
+        <p:spPr>
+          <a:xfrm>
+            <a:off x="3794760" y="2980944"/>
+            <a:ext cx="731520" cy="658368"/>
+          </a:xfrm>
+          <a:prstGeom prst="rect">
+            <a:avLst/>
+          </a:prstGeom>
+          <a:solidFill>
+            <a:srgbClr val="F8FAFD"/>
+          </a:solidFill>
+          <a:ln>
+            <a:solidFill>
+              <a:srgbClr val="B4C2D6"/>
+            </a:solidFill>
+          </a:ln>
+        </p:spPr>
+        <p:style>
+          <a:lnRef idx="1">
+            <a:schemeClr val="accent1"/>
+          </a:lnRef>
+          <a:fillRef idx="3">
+            <a:schemeClr val="accent1"/>
+          </a:fillRef>
+          <a:effectRef idx="2">
+            <a:schemeClr val="accent1"/>
+          </a:effectRef>
+          <a:fontRef idx="minor">
+            <a:schemeClr val="lt1"/>
+          </a:fontRef>
+        </p:style>
+        <p:txBody>
+          <a:bodyPr wrap="square" rtlCol="0" anchor="ctr"/>
+          <a:lstStyle/>
+          <a:p>
+            <a:pPr algn="ctr"/>
+            <a:r>
+              <a:rPr sz="1050">
+                <a:solidFill>
+                  <a:srgbClr val="282828"/>
+                </a:solidFill>
+                <a:latin typeface="Aptos"/>
+              </a:rPr>
+              <a:t>15</a:t>
+            </a:r>
+            <a:endParaRPr sz="1050">
+              <a:solidFill>
+                <a:srgbClr val="282828"/>
+              </a:solidFill>
+              <a:latin typeface="Aptos"/>
+            </a:endParaRPr>
+          </a:p>
+        </p:txBody>
+      </p:sp>
+      <p:sp>
+        <p:nvSpPr>
+          <p:cNvPr id="22" name="Rectangle 14"/>
+          <p:cNvSpPr/>
+          <p:nvPr/>
+        </p:nvSpPr>
+        <p:spPr>
+          <a:xfrm>
+            <a:off x="4709160" y="2980944"/>
+            <a:ext cx="6812280" cy="658368"/>
+          </a:xfrm>
+          <a:prstGeom prst="rect">
+            <a:avLst/>
+          </a:prstGeom>
+          <a:solidFill>
+            <a:srgbClr val="F8FAFD"/>
+          </a:solidFill>
+          <a:ln>
+            <a:solidFill>
+              <a:srgbClr val="B4C2D6"/>
+            </a:solidFill>
+          </a:ln>
+        </p:spPr>
+        <p:style>
+          <a:lnRef idx="1">
+            <a:schemeClr val="accent1"/>
+          </a:lnRef>
+          <a:fillRef idx="3">
+            <a:schemeClr val="accent1"/>
+          </a:fillRef>
+          <a:effectRef idx="2">
+            <a:schemeClr val="accent1"/>
+          </a:effectRef>
+          <a:fontRef idx="minor">
+            <a:schemeClr val="lt1"/>
+          </a:fontRef>
+        </p:style>
+        <p:txBody>
+          <a:bodyPr wrap="square" rtlCol="0" anchor="ctr"/>
+          <a:lstStyle/>
+          <a:p>
+            <a:pPr algn="l"/>
+            <a:r>
+              <a:rPr sz="1000">
+                <a:solidFill>
+                  <a:srgbClr val="282828"/>
+                </a:solidFill>
+                <a:latin typeface="Aptos"/>
+              </a:rPr>
+              <a:t>Full CRUD lifecycle, validation, 404/401 behaviour, pagination constraints</a:t>
+            </a:r>
+            <a:endParaRPr sz="1000">
+              <a:solidFill>
+                <a:srgbClr val="282828"/>
+              </a:solidFill>
+              <a:latin typeface="Aptos"/>
+            </a:endParaRPr>
+          </a:p>
+        </p:txBody>
+      </p:sp>
+      <p:sp>
+        <p:nvSpPr>
+          <p:cNvPr id="23" name="Rectangle 15"/>
+          <p:cNvSpPr/>
+          <p:nvPr/>
+        </p:nvSpPr>
+        <p:spPr>
+          <a:xfrm>
+            <a:off x="594360" y="3639311"/>
+            <a:ext cx="3017520" cy="658368"/>
+          </a:xfrm>
+          <a:prstGeom prst="rect">
+            <a:avLst/>
+          </a:prstGeom>
+          <a:solidFill>
+            <a:srgbClr val="EFF4FA"/>
+          </a:solidFill>
+          <a:ln>
+            <a:solidFill>
+              <a:srgbClr val="B4C2D6"/>
+            </a:solidFill>
+          </a:ln>
+        </p:spPr>
+        <p:style>
+          <a:lnRef idx="1">
+            <a:schemeClr val="accent1"/>
+          </a:lnRef>
+          <a:fillRef idx="3">
+            <a:schemeClr val="accent1"/>
+          </a:fillRef>
+          <a:effectRef idx="2">
+            <a:schemeClr val="accent1"/>
+          </a:effectRef>
+          <a:fontRef idx="minor">
+            <a:schemeClr val="lt1"/>
+          </a:fontRef>
+        </p:style>
+        <p:txBody>
+          <a:bodyPr wrap="square" rtlCol="0" anchor="ctr"/>
+          <a:lstStyle/>
+          <a:p>
+            <a:pPr algn="l"/>
+            <a:r>
+              <a:rPr sz="1050" b="1">
+                <a:solidFill>
+                  <a:srgbClr val="282828"/>
+                </a:solidFill>
+                <a:latin typeface="Aptos"/>
+              </a:rPr>
+              <a:t>test_api_negative.py</a:t>
+            </a:r>
+            <a:endParaRPr sz="1050" b="1">
+              <a:solidFill>
+                <a:srgbClr val="282828"/>
+              </a:solidFill>
+              <a:latin typeface="Aptos"/>
+            </a:endParaRPr>
+          </a:p>
+        </p:txBody>
+      </p:sp>
+      <p:sp>
+        <p:nvSpPr>
+          <p:cNvPr id="24" name="Rectangle 16"/>
+          <p:cNvSpPr/>
+          <p:nvPr/>
+        </p:nvSpPr>
+        <p:spPr>
+          <a:xfrm>
+            <a:off x="3794760" y="3639311"/>
+            <a:ext cx="731520" cy="658368"/>
+          </a:xfrm>
+          <a:prstGeom prst="rect">
+            <a:avLst/>
+          </a:prstGeom>
+          <a:solidFill>
+            <a:srgbClr val="EFF4FA"/>
+          </a:solidFill>
+          <a:ln>
+            <a:solidFill>
+              <a:srgbClr val="B4C2D6"/>
+            </a:solidFill>
+          </a:ln>
+        </p:spPr>
+        <p:style>
+          <a:lnRef idx="1">
+            <a:schemeClr val="accent1"/>
+          </a:lnRef>
+          <a:fillRef idx="3">
+            <a:schemeClr val="accent1"/>
+          </a:fillRef>
+          <a:effectRef idx="2">
+            <a:schemeClr val="accent1"/>
+          </a:effectRef>
+          <a:fontRef idx="minor">
+            <a:schemeClr val="lt1"/>
+          </a:fontRef>
+        </p:style>
+        <p:txBody>
+          <a:bodyPr wrap="square" rtlCol="0" anchor="ctr"/>
+          <a:lstStyle/>
+          <a:p>
+            <a:pPr algn="ctr"/>
+            <a:r>
+              <a:rPr sz="1050">
+                <a:solidFill>
+                  <a:srgbClr val="282828"/>
+                </a:solidFill>
+                <a:latin typeface="Aptos"/>
+              </a:rPr>
+              <a:t>26</a:t>
+            </a:r>
+            <a:endParaRPr sz="1050">
+              <a:solidFill>
+                <a:srgbClr val="282828"/>
+              </a:solidFill>
+              <a:latin typeface="Aptos"/>
+            </a:endParaRPr>
+          </a:p>
+        </p:txBody>
+      </p:sp>
+      <p:sp>
+        <p:nvSpPr>
+          <p:cNvPr id="26" name="Rectangle 17"/>
+          <p:cNvSpPr/>
+          <p:nvPr/>
+        </p:nvSpPr>
+        <p:spPr>
+          <a:xfrm>
+            <a:off x="4709160" y="3639311"/>
+            <a:ext cx="6812280" cy="658368"/>
+          </a:xfrm>
+          <a:prstGeom prst="rect">
+            <a:avLst/>
+          </a:prstGeom>
+          <a:solidFill>
+            <a:srgbClr val="EFF4FA"/>
+          </a:solidFill>
+          <a:ln>
+            <a:solidFill>
+              <a:srgbClr val="B4C2D6"/>
+            </a:solidFill>
+          </a:ln>
+        </p:spPr>
+        <p:style>
+          <a:lnRef idx="1">
+            <a:schemeClr val="accent1"/>
+          </a:lnRef>
+          <a:fillRef idx="3">
+            <a:schemeClr val="accent1"/>
+          </a:fillRef>
+          <a:effectRef idx="2">
+            <a:schemeClr val="accent1"/>
+          </a:effectRef>
+          <a:fontRef idx="minor">
+            <a:schemeClr val="lt1"/>
+          </a:fontRef>
+        </p:style>
+        <p:txBody>
+          <a:bodyPr wrap="square" rtlCol="0" anchor="ctr"/>
+          <a:lstStyle/>
+          <a:p>
+            <a:pPr algn="l"/>
+            <a:r>
+              <a:rPr sz="1000">
+                <a:solidFill>
+                  <a:srgbClr val="282828"/>
+                </a:solidFill>
+                <a:latin typeface="Aptos"/>
+              </a:rPr>
+              <a:t>Cross-endpoint negative cases: auth, invalid params, non-existent IDs/codes, malformed input</a:t>
+            </a:r>
+            <a:endParaRPr sz="1000">
+              <a:solidFill>
+                <a:srgbClr val="282828"/>
+              </a:solidFill>
+              <a:latin typeface="Aptos"/>
+            </a:endParaRPr>
+          </a:p>
+        </p:txBody>
+      </p:sp>
+      <p:sp>
+        <p:nvSpPr>
+          <p:cNvPr id="27" name="Rectangle 18"/>
+          <p:cNvSpPr/>
+          <p:nvPr/>
+        </p:nvSpPr>
+        <p:spPr>
+          <a:xfrm>
+            <a:off x="594360" y="4297679"/>
+            <a:ext cx="3017520" cy="658368"/>
+          </a:xfrm>
+          <a:prstGeom prst="rect">
+            <a:avLst/>
+          </a:prstGeom>
+          <a:solidFill>
+            <a:srgbClr val="F8FAFD"/>
+          </a:solidFill>
+          <a:ln>
+            <a:solidFill>
+              <a:srgbClr val="B4C2D6"/>
+            </a:solidFill>
+          </a:ln>
+        </p:spPr>
+        <p:style>
+          <a:lnRef idx="1">
+            <a:schemeClr val="accent1"/>
+          </a:lnRef>
+          <a:fillRef idx="3">
+            <a:schemeClr val="accent1"/>
+          </a:fillRef>
+          <a:effectRef idx="2">
+            <a:schemeClr val="accent1"/>
+          </a:effectRef>
+          <a:fontRef idx="minor">
+            <a:schemeClr val="lt1"/>
+          </a:fontRef>
+        </p:style>
+        <p:txBody>
+          <a:bodyPr wrap="square" rtlCol="0" anchor="ctr"/>
+          <a:lstStyle/>
+          <a:p>
+            <a:pPr algn="l"/>
+            <a:r>
+              <a:rPr sz="1050" b="1">
+                <a:solidFill>
+                  <a:srgbClr val="282828"/>
+                </a:solidFill>
+                <a:latin typeface="Aptos"/>
+              </a:rPr>
+              <a:t>test_multistep_agent.py</a:t>
+            </a:r>
+            <a:endParaRPr sz="1050" b="1">
+              <a:solidFill>
+                <a:srgbClr val="282828"/>
+              </a:solidFill>
+              <a:latin typeface="Aptos"/>
+            </a:endParaRPr>
+          </a:p>
+        </p:txBody>
+      </p:sp>
+      <p:sp>
+        <p:nvSpPr>
+          <p:cNvPr id="28" name="Rectangle 19"/>
+          <p:cNvSpPr/>
+          <p:nvPr/>
+        </p:nvSpPr>
+        <p:spPr>
+          <a:xfrm>
+            <a:off x="3794760" y="4297679"/>
+            <a:ext cx="731520" cy="658368"/>
+          </a:xfrm>
+          <a:prstGeom prst="rect">
+            <a:avLst/>
+          </a:prstGeom>
+          <a:solidFill>
+            <a:srgbClr val="F8FAFD"/>
+          </a:solidFill>
+          <a:ln>
+            <a:solidFill>
+              <a:srgbClr val="B4C2D6"/>
+            </a:solidFill>
+          </a:ln>
+        </p:spPr>
+        <p:style>
+          <a:lnRef idx="1">
+            <a:schemeClr val="accent1"/>
+          </a:lnRef>
+          <a:fillRef idx="3">
+            <a:schemeClr val="accent1"/>
+          </a:fillRef>
+          <a:effectRef idx="2">
+            <a:schemeClr val="accent1"/>
+          </a:effectRef>
+          <a:fontRef idx="minor">
+            <a:schemeClr val="lt1"/>
+          </a:fontRef>
+        </p:style>
+        <p:txBody>
+          <a:bodyPr wrap="square" rtlCol="0" anchor="ctr"/>
+          <a:lstStyle/>
+          <a:p>
+            <a:pPr algn="ctr"/>
+            <a:r>
+              <a:rPr sz="1050">
+                <a:solidFill>
+                  <a:srgbClr val="282828"/>
+                </a:solidFill>
+                <a:latin typeface="Aptos"/>
+              </a:rPr>
+              <a:t>11</a:t>
+            </a:r>
+            <a:endParaRPr sz="1050">
+              <a:solidFill>
+                <a:srgbClr val="282828"/>
+              </a:solidFill>
+              <a:latin typeface="Aptos"/>
+            </a:endParaRPr>
+          </a:p>
+        </p:txBody>
+      </p:sp>
+      <p:sp>
+        <p:nvSpPr>
+          <p:cNvPr id="29" name="Rectangle 20"/>
+          <p:cNvSpPr/>
+          <p:nvPr/>
+        </p:nvSpPr>
+        <p:spPr>
+          <a:xfrm>
+            <a:off x="4709160" y="4297679"/>
+            <a:ext cx="6812280" cy="658368"/>
+          </a:xfrm>
+          <a:prstGeom prst="rect">
+            <a:avLst/>
+          </a:prstGeom>
+          <a:solidFill>
+            <a:srgbClr val="F8FAFD"/>
+          </a:solidFill>
+          <a:ln>
+            <a:solidFill>
+              <a:srgbClr val="B4C2D6"/>
+            </a:solidFill>
+          </a:ln>
+        </p:spPr>
+        <p:style>
+          <a:lnRef idx="1">
+            <a:schemeClr val="accent1"/>
+          </a:lnRef>
+          <a:fillRef idx="3">
+            <a:schemeClr val="accent1"/>
+          </a:fillRef>
+          <a:effectRef idx="2">
+            <a:schemeClr val="accent1"/>
+          </a:effectRef>
+          <a:fontRef idx="minor">
+            <a:schemeClr val="lt1"/>
+          </a:fontRef>
+        </p:style>
+        <p:txBody>
+          <a:bodyPr wrap="square" rtlCol="0" anchor="ctr"/>
+          <a:lstStyle/>
+          <a:p>
+            <a:pPr algn="l"/>
+            <a:r>
+              <a:rPr sz="1000">
+                <a:solidFill>
+                  <a:srgbClr val="282828"/>
+                </a:solidFill>
+                <a:latin typeface="Aptos"/>
+              </a:rPr>
+              <a:t>Schema-before-code ordering, multistep reasoning, tool trace completeness, jailbreak resilience</a:t>
+            </a:r>
+            <a:endParaRPr sz="1000">
+              <a:solidFill>
+                <a:srgbClr val="282828"/>
+              </a:solidFill>
+              <a:latin typeface="Aptos"/>
+            </a:endParaRPr>
+          </a:p>
+        </p:txBody>
+      </p:sp>
+      <p:sp>
+        <p:nvSpPr>
+          <p:cNvPr id="30" name="Rectangle 21"/>
+          <p:cNvSpPr/>
+          <p:nvPr/>
+        </p:nvSpPr>
+        <p:spPr>
+          <a:xfrm>
+            <a:off x="594360" y="4956047"/>
+            <a:ext cx="3017520" cy="658368"/>
+          </a:xfrm>
+          <a:prstGeom prst="rect">
+            <a:avLst/>
+          </a:prstGeom>
+          <a:solidFill>
+            <a:srgbClr val="EFF4FA"/>
+          </a:solidFill>
+          <a:ln>
+            <a:solidFill>
+              <a:srgbClr val="B4C2D6"/>
+            </a:solidFill>
+          </a:ln>
+        </p:spPr>
+        <p:style>
+          <a:lnRef idx="1">
+            <a:schemeClr val="accent1"/>
+          </a:lnRef>
+          <a:fillRef idx="3">
+            <a:schemeClr val="accent1"/>
+          </a:fillRef>
+          <a:effectRef idx="2">
+            <a:schemeClr val="accent1"/>
+          </a:effectRef>
+          <a:fontRef idx="minor">
+            <a:schemeClr val="lt1"/>
+          </a:fontRef>
+        </p:style>
+        <p:txBody>
+          <a:bodyPr wrap="square" rtlCol="0" anchor="ctr"/>
+          <a:lstStyle/>
+          <a:p>
+            <a:pPr algn="l"/>
+            <a:r>
+              <a:rPr sz="1050" b="1">
+                <a:solidFill>
+                  <a:srgbClr val="282828"/>
+                </a:solidFill>
+                <a:latin typeface="Aptos"/>
+              </a:rPr>
+              <a:t>test_anomaly_detection.py</a:t>
+            </a:r>
+            <a:endParaRPr sz="1050" b="1">
+              <a:solidFill>
+                <a:srgbClr val="282828"/>
+              </a:solidFill>
+              <a:latin typeface="Aptos"/>
+            </a:endParaRPr>
+          </a:p>
+        </p:txBody>
+      </p:sp>
+      <p:sp>
+        <p:nvSpPr>
+          <p:cNvPr id="31" name="Rectangle 22"/>
+          <p:cNvSpPr/>
+          <p:nvPr/>
+        </p:nvSpPr>
+        <p:spPr>
+          <a:xfrm>
+            <a:off x="3794760" y="4956047"/>
+            <a:ext cx="731520" cy="658368"/>
+          </a:xfrm>
+          <a:prstGeom prst="rect">
+            <a:avLst/>
+          </a:prstGeom>
+          <a:solidFill>
+            <a:srgbClr val="EFF4FA"/>
+          </a:solidFill>
+          <a:ln>
+            <a:solidFill>
+              <a:srgbClr val="B4C2D6"/>
+            </a:solidFill>
+          </a:ln>
+        </p:spPr>
+        <p:style>
+          <a:lnRef idx="1">
+            <a:schemeClr val="accent1"/>
+          </a:lnRef>
+          <a:fillRef idx="3">
+            <a:schemeClr val="accent1"/>
+          </a:fillRef>
+          <a:effectRef idx="2">
+            <a:schemeClr val="accent1"/>
+          </a:effectRef>
+          <a:fontRef idx="minor">
+            <a:schemeClr val="lt1"/>
+          </a:fontRef>
+        </p:style>
+        <p:txBody>
+          <a:bodyPr wrap="square" rtlCol="0" anchor="ctr"/>
+          <a:lstStyle/>
+          <a:p>
+            <a:pPr algn="ctr"/>
+            <a:r>
+              <a:rPr sz="1050">
+                <a:solidFill>
+                  <a:srgbClr val="282828"/>
+                </a:solidFill>
+                <a:latin typeface="Aptos"/>
+              </a:rPr>
+              <a:t>11</a:t>
+            </a:r>
+            <a:endParaRPr sz="1050">
+              <a:solidFill>
+                <a:srgbClr val="282828"/>
+              </a:solidFill>
+              <a:latin typeface="Aptos"/>
+            </a:endParaRPr>
+          </a:p>
+        </p:txBody>
+      </p:sp>
+      <p:sp>
+        <p:nvSpPr>
+          <p:cNvPr id="32" name="Rectangle 23"/>
+          <p:cNvSpPr/>
+          <p:nvPr/>
+        </p:nvSpPr>
+        <p:spPr>
+          <a:xfrm>
+            <a:off x="4709160" y="4956047"/>
+            <a:ext cx="6812280" cy="658368"/>
+          </a:xfrm>
+          <a:prstGeom prst="rect">
+            <a:avLst/>
+          </a:prstGeom>
+          <a:solidFill>
+            <a:srgbClr val="EFF4FA"/>
+          </a:solidFill>
+          <a:ln>
+            <a:solidFill>
+              <a:srgbClr val="B4C2D6"/>
+            </a:solidFill>
+          </a:ln>
+        </p:spPr>
+        <p:style>
+          <a:lnRef idx="1">
+            <a:schemeClr val="accent1"/>
+          </a:lnRef>
+          <a:fillRef idx="3">
+            <a:schemeClr val="accent1"/>
+          </a:fillRef>
+          <a:effectRef idx="2">
+            <a:schemeClr val="accent1"/>
+          </a:effectRef>
+          <a:fontRef idx="minor">
+            <a:schemeClr val="lt1"/>
+          </a:fontRef>
+        </p:style>
+        <p:txBody>
+          <a:bodyPr wrap="square" rtlCol="0" anchor="ctr"/>
+          <a:lstStyle/>
+          <a:p>
+            <a:pPr algn="l"/>
+            <a:r>
+              <a:rPr sz="1000">
+                <a:solidFill>
+                  <a:srgbClr val="282828"/>
+                </a:solidFill>
+                <a:latin typeface="Aptos"/>
+              </a:rPr>
+              <a:t>Dead-stock detection, margin checks, overdue shipping, NLQ anomaly explanation, auto-save</a:t>
+            </a:r>
+            <a:endParaRPr sz="1000">
+              <a:solidFill>
+                <a:srgbClr val="282828"/>
+              </a:solidFill>
+              <a:latin typeface="Aptos"/>
+            </a:endParaRPr>
+          </a:p>
+        </p:txBody>
+      </p:sp>
+      <p:sp>
+        <p:nvSpPr>
+          <p:cNvPr id="33" name="Rounded Rectangle 24"/>
+          <p:cNvSpPr/>
+          <p:nvPr/>
+        </p:nvSpPr>
+        <p:spPr>
+          <a:xfrm>
+            <a:off x="594360" y="5806440"/>
+            <a:ext cx="10972800" cy="640080"/>
+          </a:xfrm>
+          <a:prstGeom prst="roundRect">
+            <a:avLst/>
+          </a:prstGeom>
+          <a:solidFill>
+            <a:srgbClr val="F4F8FD"/>
+          </a:solidFill>
+          <a:ln w="15240">
+            <a:solidFill>
+              <a:srgbClr val="B4C2D6"/>
+            </a:solidFill>
+          </a:ln>
+        </p:spPr>
+        <p:style>
+          <a:lnRef idx="1">
+            <a:schemeClr val="accent1"/>
+          </a:lnRef>
+          <a:fillRef idx="3">
+            <a:schemeClr val="accent1"/>
+          </a:fillRef>
+          <a:effectRef idx="2">
+            <a:schemeClr val="accent1"/>
+          </a:effectRef>
+          <a:fontRef idx="minor">
+            <a:schemeClr val="lt1"/>
+          </a:fontRef>
+        </p:style>
+        <p:txBody>
+          <a:bodyPr wrap="square" rtlCol="0" anchor="ctr"/>
+          <a:lstStyle/>
+          <a:p>
+            <a:pPr algn="ctr"/>
+            <a:r>
+              <a:rPr sz="1500" b="1">
+                <a:solidFill>
+                  <a:srgbClr val="2E5488"/>
+                </a:solidFill>
+                <a:latin typeface="Aptos"/>
+              </a:rPr>
+              <a:t>Takeaway</a:t>
+            </a:r>
+            <a:endParaRPr sz="1500" b="1">
+              <a:solidFill>
+                <a:srgbClr val="2E5488"/>
+              </a:solidFill>
+              <a:latin typeface="Aptos"/>
+            </a:endParaRPr>
+          </a:p>
+          <a:p>
+            <a:pPr>
+              <a:defRPr sz="1100">
+                <a:solidFill>
+                  <a:srgbClr val="282828"/>
+                </a:solidFill>
+                <a:latin typeface="Aptos"/>
+              </a:defRPr>
+            </a:pPr>
+            <a:r>
+              <a:t>The testing evidence supports both software-engineering quality (CRUD, validation, error handling) and AI-layer credibility (tool use, security, multistep reasoning).</a:t>
+            </a:r>
+          </a:p>
+        </p:txBody>
+      </p:sp>
     </p:spTree>
   </p:cSld>
   <p:clrMapOvr>
@@ -4925,7 +7376,7 @@
         <p:spPr>
           <a:xfrm>
             <a:off x="731520" y="1417320"/>
-            <a:ext cx="2514600" cy="1417320"/>
+            <a:ext cx="2514600" cy="1950085"/>
           </a:xfrm>
           <a:prstGeom prst="roundRect">
             <a:avLst>
@@ -4949,6 +7400,12 @@
             </a:outerShdw>
           </a:effectLst>
         </p:spPr>
+        <p:txBody>
+          <a:bodyPr/>
+          <a:p>
+            <a:endParaRPr lang="zh-CN" altLang="en-US"/>
+          </a:p>
+        </p:txBody>
       </p:sp>
       <p:sp>
         <p:nvSpPr>
@@ -4978,6 +7435,7 @@
                 <a:solidFill>
                   <a:srgbClr val="0F172A"/>
                 </a:solidFill>
+                <a:hlinkClick r:id="rId1" action="ppaction://hlinkfile"/>
               </a:rPr>
               <a:t>Code repository</a:t>
             </a:r>
@@ -5029,7 +7487,7 @@
         <p:spPr>
           <a:xfrm>
             <a:off x="3474720" y="1417320"/>
-            <a:ext cx="2514600" cy="1417320"/>
+            <a:ext cx="2514600" cy="1927860"/>
           </a:xfrm>
           <a:prstGeom prst="roundRect">
             <a:avLst>
@@ -5082,6 +7540,7 @@
                 <a:solidFill>
                   <a:srgbClr val="0F172A"/>
                 </a:solidFill>
+                <a:hlinkClick r:id="rId2" action="ppaction://hlinkfile"/>
               </a:rPr>
               <a:t>API documentation</a:t>
             </a:r>
@@ -5133,7 +7592,7 @@
         <p:spPr>
           <a:xfrm>
             <a:off x="6217920" y="1417320"/>
-            <a:ext cx="2514600" cy="1417320"/>
+            <a:ext cx="2514600" cy="1922780"/>
           </a:xfrm>
           <a:prstGeom prst="roundRect">
             <a:avLst>
@@ -5186,6 +7645,7 @@
                 <a:solidFill>
                   <a:srgbClr val="0F172A"/>
                 </a:solidFill>
+                <a:hlinkClick r:id="rId3" action="ppaction://hlinkfile"/>
               </a:rPr>
               <a:t>Technical report</a:t>
             </a:r>
@@ -5237,7 +7697,7 @@
         <p:spPr>
           <a:xfrm>
             <a:off x="8961120" y="1417320"/>
-            <a:ext cx="2514600" cy="1417320"/>
+            <a:ext cx="2514600" cy="1888490"/>
           </a:xfrm>
           <a:prstGeom prst="roundRect">
             <a:avLst>
@@ -5290,6 +7750,7 @@
                 <a:solidFill>
                   <a:srgbClr val="0F172A"/>
                 </a:solidFill>
+                <a:hlinkClick r:id="rId4" action="ppaction://hlinkfile"/>
               </a:rPr>
               <a:t>Presentation slides</a:t>
             </a:r>
@@ -5340,7 +7801,7 @@
         </p:nvSpPr>
         <p:spPr>
           <a:xfrm>
-            <a:off x="1325880" y="3383280"/>
+            <a:off x="1325880" y="3705860"/>
             <a:ext cx="4114800" cy="1234440"/>
           </a:xfrm>
           <a:prstGeom prst="roundRect">
@@ -5374,7 +7835,7 @@
         </p:nvSpPr>
         <p:spPr>
           <a:xfrm>
-            <a:off x="1472184" y="3493008"/>
+            <a:off x="1463294" y="3791458"/>
             <a:ext cx="3840480" cy="256032"/>
           </a:xfrm>
           <a:prstGeom prst="rect">
@@ -5409,7 +7870,7 @@
         </p:nvSpPr>
         <p:spPr>
           <a:xfrm>
-            <a:off x="1472184" y="3794760"/>
+            <a:off x="1463294" y="4102735"/>
             <a:ext cx="3840480" cy="740664"/>
           </a:xfrm>
           <a:prstGeom prst="rect">
@@ -5444,7 +7905,7 @@
         </p:nvSpPr>
         <p:spPr>
           <a:xfrm>
-            <a:off x="6400800" y="3383280"/>
+            <a:off x="6400800" y="3705860"/>
             <a:ext cx="4114800" cy="1234440"/>
           </a:xfrm>
           <a:prstGeom prst="roundRect">
@@ -5478,7 +7939,7 @@
         </p:nvSpPr>
         <p:spPr>
           <a:xfrm>
-            <a:off x="6547104" y="3493008"/>
+            <a:off x="6547104" y="3791458"/>
             <a:ext cx="3840480" cy="256032"/>
           </a:xfrm>
           <a:prstGeom prst="rect">
@@ -5513,7 +7974,7 @@
         </p:nvSpPr>
         <p:spPr>
           <a:xfrm>
-            <a:off x="6547104" y="3794760"/>
+            <a:off x="6547104" y="4102735"/>
             <a:ext cx="3840480" cy="740664"/>
           </a:xfrm>
           <a:prstGeom prst="rect">
@@ -5936,9 +8397,51 @@
           </a:p>
         </p:txBody>
       </p:sp>
+      <p:sp>
+        <p:nvSpPr>
+          <p:cNvPr id="25" name="Slide Number Placeholder 0"/>
+          <p:cNvSpPr>
+            <a:spLocks noGrp="1"/>
+          </p:cNvSpPr>
+          <p:nvPr>
+            <p:ph type="sldNum" sz="quarter" idx="4294967295"/>
+          </p:nvPr>
+        </p:nvSpPr>
+        <p:spPr>
+          <a:xfrm>
+            <a:off x="11567160" y="6473952"/>
+            <a:ext cx="274320" cy="182880"/>
+          </a:xfrm>
+          <a:prstGeom prst="rect">
+            <a:avLst/>
+          </a:prstGeom>
+        </p:spPr>
+        <p:txBody>
+          <a:bodyPr/>
+          <a:lstStyle>
+            <a:lvl1pPr>
+              <a:defRPr sz="1000">
+                <a:solidFill>
+                  <a:srgbClr val="64748B"/>
+                </a:solidFill>
+                <a:latin typeface="Aptos"/>
+                <a:ea typeface="Aptos"/>
+                <a:cs typeface="Aptos"/>
+              </a:defRPr>
+            </a:lvl1pPr>
+          </a:lstStyle>
+          <a:p>
+            <a:pPr algn="ctr"/>
+            <a:fld id="{F7021451-1387-4CA6-816F-3879F97B5CBC}" type="slidenum">
+              <a:rPr lang="en-US" b="0"/>
+            </a:fld>
+            <a:endParaRPr lang="en-US"/>
+          </a:p>
+        </p:txBody>
+      </p:sp>
       <p:pic>
         <p:nvPicPr>
-          <p:cNvPr id="7" name="Image 0" descr="/mnt/data/ppt_build/sequence_flow2.png"/>
+          <p:cNvPr id="8" name="图片 7" descr="3"/>
           <p:cNvPicPr>
             <a:picLocks noChangeAspect="1"/>
           </p:cNvPicPr>
@@ -5952,56 +8455,14 @@
         </p:blipFill>
         <p:spPr>
           <a:xfrm>
-            <a:off x="4526280" y="1534970"/>
-            <a:ext cx="7086600" cy="3970940"/>
+            <a:off x="4300855" y="1234440"/>
+            <a:ext cx="7891145" cy="4617085"/>
           </a:xfrm>
           <a:prstGeom prst="rect">
             <a:avLst/>
           </a:prstGeom>
         </p:spPr>
       </p:pic>
-      <p:sp>
-        <p:nvSpPr>
-          <p:cNvPr id="25" name="Slide Number Placeholder 0"/>
-          <p:cNvSpPr>
-            <a:spLocks noGrp="1"/>
-          </p:cNvSpPr>
-          <p:nvPr>
-            <p:ph type="sldNum" sz="quarter" idx="4294967295"/>
-          </p:nvPr>
-        </p:nvSpPr>
-        <p:spPr>
-          <a:xfrm>
-            <a:off x="11567160" y="6473952"/>
-            <a:ext cx="274320" cy="182880"/>
-          </a:xfrm>
-          <a:prstGeom prst="rect">
-            <a:avLst/>
-          </a:prstGeom>
-        </p:spPr>
-        <p:txBody>
-          <a:bodyPr/>
-          <a:lstStyle>
-            <a:lvl1pPr>
-              <a:defRPr sz="1000">
-                <a:solidFill>
-                  <a:srgbClr val="64748B"/>
-                </a:solidFill>
-                <a:latin typeface="Aptos"/>
-                <a:ea typeface="Aptos"/>
-                <a:cs typeface="Aptos"/>
-              </a:defRPr>
-            </a:lvl1pPr>
-          </a:lstStyle>
-          <a:p>
-            <a:pPr algn="ctr"/>
-            <a:fld id="{F7021451-1387-4CA6-816F-3879F97B5CBC}" type="slidenum">
-              <a:rPr lang="en-US" b="0"/>
-            </a:fld>
-            <a:endParaRPr lang="en-US"/>
-          </a:p>
-        </p:txBody>
-      </p:sp>
     </p:spTree>
   </p:cSld>
   <p:clrMapOvr>

</xml_diff>